<commit_message>
add draft write up
</commit_message>
<xml_diff>
--- a/images.pptx
+++ b/images.pptx
@@ -15,6 +15,7 @@
     <p:sldId id="265" r:id="rId9"/>
     <p:sldId id="266" r:id="rId10"/>
     <p:sldId id="267" r:id="rId11"/>
+    <p:sldId id="268" r:id="rId12"/>
   </p:sldIdLst>
   <p:sldSz cx="12192000" cy="6858000"/>
   <p:notesSz cx="6858000" cy="9144000"/>
@@ -113,6 +114,11 @@
       </a:defRPr>
     </a:lvl9pPr>
   </p:defaultTextStyle>
+  <p:extLst>
+    <p:ext uri="{EFAFB233-063F-42B5-8137-9DF3F51BA10A}">
+      <p15:sldGuideLst xmlns:p15="http://schemas.microsoft.com/office/powerpoint/2012/main"/>
+    </p:ext>
+  </p:extLst>
 </p:presentation>
 </file>
 
@@ -265,7 +271,7 @@
           <a:p>
             <a:fld id="{C66642F0-F67B-EC40-91BE-EF08B282755F}" type="datetimeFigureOut">
               <a:rPr lang="en-US" smtClean="0"/>
-              <a:t>1/2/26</a:t>
+              <a:t>4/14/26</a:t>
             </a:fld>
             <a:endParaRPr lang="en-US"/>
           </a:p>
@@ -465,7 +471,7 @@
           <a:p>
             <a:fld id="{C66642F0-F67B-EC40-91BE-EF08B282755F}" type="datetimeFigureOut">
               <a:rPr lang="en-US" smtClean="0"/>
-              <a:t>1/2/26</a:t>
+              <a:t>4/14/26</a:t>
             </a:fld>
             <a:endParaRPr lang="en-US"/>
           </a:p>
@@ -675,7 +681,7 @@
           <a:p>
             <a:fld id="{C66642F0-F67B-EC40-91BE-EF08B282755F}" type="datetimeFigureOut">
               <a:rPr lang="en-US" smtClean="0"/>
-              <a:t>1/2/26</a:t>
+              <a:t>4/14/26</a:t>
             </a:fld>
             <a:endParaRPr lang="en-US"/>
           </a:p>
@@ -875,7 +881,7 @@
           <a:p>
             <a:fld id="{C66642F0-F67B-EC40-91BE-EF08B282755F}" type="datetimeFigureOut">
               <a:rPr lang="en-US" smtClean="0"/>
-              <a:t>1/2/26</a:t>
+              <a:t>4/14/26</a:t>
             </a:fld>
             <a:endParaRPr lang="en-US"/>
           </a:p>
@@ -1151,7 +1157,7 @@
           <a:p>
             <a:fld id="{C66642F0-F67B-EC40-91BE-EF08B282755F}" type="datetimeFigureOut">
               <a:rPr lang="en-US" smtClean="0"/>
-              <a:t>1/2/26</a:t>
+              <a:t>4/14/26</a:t>
             </a:fld>
             <a:endParaRPr lang="en-US"/>
           </a:p>
@@ -1419,7 +1425,7 @@
           <a:p>
             <a:fld id="{C66642F0-F67B-EC40-91BE-EF08B282755F}" type="datetimeFigureOut">
               <a:rPr lang="en-US" smtClean="0"/>
-              <a:t>1/2/26</a:t>
+              <a:t>4/14/26</a:t>
             </a:fld>
             <a:endParaRPr lang="en-US"/>
           </a:p>
@@ -1834,7 +1840,7 @@
           <a:p>
             <a:fld id="{C66642F0-F67B-EC40-91BE-EF08B282755F}" type="datetimeFigureOut">
               <a:rPr lang="en-US" smtClean="0"/>
-              <a:t>1/2/26</a:t>
+              <a:t>4/14/26</a:t>
             </a:fld>
             <a:endParaRPr lang="en-US"/>
           </a:p>
@@ -1976,7 +1982,7 @@
           <a:p>
             <a:fld id="{C66642F0-F67B-EC40-91BE-EF08B282755F}" type="datetimeFigureOut">
               <a:rPr lang="en-US" smtClean="0"/>
-              <a:t>1/2/26</a:t>
+              <a:t>4/14/26</a:t>
             </a:fld>
             <a:endParaRPr lang="en-US"/>
           </a:p>
@@ -2089,7 +2095,7 @@
           <a:p>
             <a:fld id="{C66642F0-F67B-EC40-91BE-EF08B282755F}" type="datetimeFigureOut">
               <a:rPr lang="en-US" smtClean="0"/>
-              <a:t>1/2/26</a:t>
+              <a:t>4/14/26</a:t>
             </a:fld>
             <a:endParaRPr lang="en-US"/>
           </a:p>
@@ -2402,7 +2408,7 @@
           <a:p>
             <a:fld id="{C66642F0-F67B-EC40-91BE-EF08B282755F}" type="datetimeFigureOut">
               <a:rPr lang="en-US" smtClean="0"/>
-              <a:t>1/2/26</a:t>
+              <a:t>4/14/26</a:t>
             </a:fld>
             <a:endParaRPr lang="en-US"/>
           </a:p>
@@ -2691,7 +2697,7 @@
           <a:p>
             <a:fld id="{C66642F0-F67B-EC40-91BE-EF08B282755F}" type="datetimeFigureOut">
               <a:rPr lang="en-US" smtClean="0"/>
-              <a:t>1/2/26</a:t>
+              <a:t>4/14/26</a:t>
             </a:fld>
             <a:endParaRPr lang="en-US"/>
           </a:p>
@@ -2934,7 +2940,7 @@
           <a:p>
             <a:fld id="{C66642F0-F67B-EC40-91BE-EF08B282755F}" type="datetimeFigureOut">
               <a:rPr lang="en-US" smtClean="0"/>
-              <a:t>1/2/26</a:t>
+              <a:t>4/14/26</a:t>
             </a:fld>
             <a:endParaRPr lang="en-US"/>
           </a:p>
@@ -3414,10 +3420,10 @@
           <p:nvPr/>
         </p:nvPicPr>
         <p:blipFill>
-          <a:blip r:embed="rId2">
+          <a:blip>
             <a:extLst>
               <a:ext uri="{96DAC541-7B7A-43D3-8B79-37D633B846F1}">
-                <asvg:svgBlip xmlns:asvg="http://schemas.microsoft.com/office/drawing/2016/SVG/main" r:embed="rId3"/>
+                <asvg:svgBlip xmlns:asvg="http://schemas.microsoft.com/office/drawing/2016/SVG/main" r:embed="rId2"/>
               </a:ext>
             </a:extLst>
           </a:blip>
@@ -3450,10 +3456,10 @@
           <p:nvPr/>
         </p:nvPicPr>
         <p:blipFill>
-          <a:blip r:embed="rId2">
+          <a:blip>
             <a:extLst>
               <a:ext uri="{96DAC541-7B7A-43D3-8B79-37D633B846F1}">
-                <asvg:svgBlip xmlns:asvg="http://schemas.microsoft.com/office/drawing/2016/SVG/main" r:embed="rId3"/>
+                <asvg:svgBlip xmlns:asvg="http://schemas.microsoft.com/office/drawing/2016/SVG/main" r:embed="rId2"/>
               </a:ext>
             </a:extLst>
           </a:blip>
@@ -3486,10 +3492,10 @@
           <p:nvPr/>
         </p:nvPicPr>
         <p:blipFill>
-          <a:blip r:embed="rId2">
+          <a:blip>
             <a:extLst>
               <a:ext uri="{96DAC541-7B7A-43D3-8B79-37D633B846F1}">
-                <asvg:svgBlip xmlns:asvg="http://schemas.microsoft.com/office/drawing/2016/SVG/main" r:embed="rId3"/>
+                <asvg:svgBlip xmlns:asvg="http://schemas.microsoft.com/office/drawing/2016/SVG/main" r:embed="rId2"/>
               </a:ext>
             </a:extLst>
           </a:blip>
@@ -3522,10 +3528,10 @@
           <p:nvPr/>
         </p:nvPicPr>
         <p:blipFill>
-          <a:blip r:embed="rId2">
+          <a:blip>
             <a:extLst>
               <a:ext uri="{96DAC541-7B7A-43D3-8B79-37D633B846F1}">
-                <asvg:svgBlip xmlns:asvg="http://schemas.microsoft.com/office/drawing/2016/SVG/main" r:embed="rId3"/>
+                <asvg:svgBlip xmlns:asvg="http://schemas.microsoft.com/office/drawing/2016/SVG/main" r:embed="rId2"/>
               </a:ext>
             </a:extLst>
           </a:blip>
@@ -3558,10 +3564,10 @@
           <p:nvPr/>
         </p:nvPicPr>
         <p:blipFill>
-          <a:blip r:embed="rId2">
+          <a:blip>
             <a:extLst>
               <a:ext uri="{96DAC541-7B7A-43D3-8B79-37D633B846F1}">
-                <asvg:svgBlip xmlns:asvg="http://schemas.microsoft.com/office/drawing/2016/SVG/main" r:embed="rId3"/>
+                <asvg:svgBlip xmlns:asvg="http://schemas.microsoft.com/office/drawing/2016/SVG/main" r:embed="rId2"/>
               </a:ext>
             </a:extLst>
           </a:blip>
@@ -3594,10 +3600,10 @@
           <p:nvPr/>
         </p:nvPicPr>
         <p:blipFill>
-          <a:blip r:embed="rId2">
+          <a:blip>
             <a:extLst>
               <a:ext uri="{96DAC541-7B7A-43D3-8B79-37D633B846F1}">
-                <asvg:svgBlip xmlns:asvg="http://schemas.microsoft.com/office/drawing/2016/SVG/main" r:embed="rId3"/>
+                <asvg:svgBlip xmlns:asvg="http://schemas.microsoft.com/office/drawing/2016/SVG/main" r:embed="rId2"/>
               </a:ext>
             </a:extLst>
           </a:blip>
@@ -3630,10 +3636,10 @@
           <p:nvPr/>
         </p:nvPicPr>
         <p:blipFill>
-          <a:blip r:embed="rId2">
+          <a:blip>
             <a:extLst>
               <a:ext uri="{96DAC541-7B7A-43D3-8B79-37D633B846F1}">
-                <asvg:svgBlip xmlns:asvg="http://schemas.microsoft.com/office/drawing/2016/SVG/main" r:embed="rId3"/>
+                <asvg:svgBlip xmlns:asvg="http://schemas.microsoft.com/office/drawing/2016/SVG/main" r:embed="rId2"/>
               </a:ext>
             </a:extLst>
           </a:blip>
@@ -3666,10 +3672,10 @@
           <p:nvPr/>
         </p:nvPicPr>
         <p:blipFill>
-          <a:blip r:embed="rId2">
+          <a:blip>
             <a:extLst>
               <a:ext uri="{96DAC541-7B7A-43D3-8B79-37D633B846F1}">
-                <asvg:svgBlip xmlns:asvg="http://schemas.microsoft.com/office/drawing/2016/SVG/main" r:embed="rId3"/>
+                <asvg:svgBlip xmlns:asvg="http://schemas.microsoft.com/office/drawing/2016/SVG/main" r:embed="rId2"/>
               </a:ext>
             </a:extLst>
           </a:blip>
@@ -3702,10 +3708,10 @@
           <p:nvPr/>
         </p:nvPicPr>
         <p:blipFill>
-          <a:blip r:embed="rId2">
+          <a:blip>
             <a:extLst>
               <a:ext uri="{96DAC541-7B7A-43D3-8B79-37D633B846F1}">
-                <asvg:svgBlip xmlns:asvg="http://schemas.microsoft.com/office/drawing/2016/SVG/main" r:embed="rId3"/>
+                <asvg:svgBlip xmlns:asvg="http://schemas.microsoft.com/office/drawing/2016/SVG/main" r:embed="rId2"/>
               </a:ext>
             </a:extLst>
           </a:blip>
@@ -3738,10 +3744,10 @@
           <p:nvPr/>
         </p:nvPicPr>
         <p:blipFill>
-          <a:blip r:embed="rId2">
+          <a:blip>
             <a:extLst>
               <a:ext uri="{96DAC541-7B7A-43D3-8B79-37D633B846F1}">
-                <asvg:svgBlip xmlns:asvg="http://schemas.microsoft.com/office/drawing/2016/SVG/main" r:embed="rId3"/>
+                <asvg:svgBlip xmlns:asvg="http://schemas.microsoft.com/office/drawing/2016/SVG/main" r:embed="rId2"/>
               </a:ext>
             </a:extLst>
           </a:blip>
@@ -3774,10 +3780,10 @@
           <p:nvPr/>
         </p:nvPicPr>
         <p:blipFill>
-          <a:blip r:embed="rId2">
+          <a:blip>
             <a:extLst>
               <a:ext uri="{96DAC541-7B7A-43D3-8B79-37D633B846F1}">
-                <asvg:svgBlip xmlns:asvg="http://schemas.microsoft.com/office/drawing/2016/SVG/main" r:embed="rId3"/>
+                <asvg:svgBlip xmlns:asvg="http://schemas.microsoft.com/office/drawing/2016/SVG/main" r:embed="rId2"/>
               </a:ext>
             </a:extLst>
           </a:blip>
@@ -3810,10 +3816,10 @@
           <p:nvPr/>
         </p:nvPicPr>
         <p:blipFill>
-          <a:blip r:embed="rId2">
+          <a:blip>
             <a:extLst>
               <a:ext uri="{96DAC541-7B7A-43D3-8B79-37D633B846F1}">
-                <asvg:svgBlip xmlns:asvg="http://schemas.microsoft.com/office/drawing/2016/SVG/main" r:embed="rId3"/>
+                <asvg:svgBlip xmlns:asvg="http://schemas.microsoft.com/office/drawing/2016/SVG/main" r:embed="rId2"/>
               </a:ext>
             </a:extLst>
           </a:blip>
@@ -3846,10 +3852,10 @@
           <p:nvPr/>
         </p:nvPicPr>
         <p:blipFill>
-          <a:blip r:embed="rId2">
+          <a:blip>
             <a:extLst>
               <a:ext uri="{96DAC541-7B7A-43D3-8B79-37D633B846F1}">
-                <asvg:svgBlip xmlns:asvg="http://schemas.microsoft.com/office/drawing/2016/SVG/main" r:embed="rId3"/>
+                <asvg:svgBlip xmlns:asvg="http://schemas.microsoft.com/office/drawing/2016/SVG/main" r:embed="rId2"/>
               </a:ext>
             </a:extLst>
           </a:blip>
@@ -3882,10 +3888,10 @@
           <p:nvPr/>
         </p:nvPicPr>
         <p:blipFill>
-          <a:blip r:embed="rId2">
+          <a:blip>
             <a:extLst>
               <a:ext uri="{96DAC541-7B7A-43D3-8B79-37D633B846F1}">
-                <asvg:svgBlip xmlns:asvg="http://schemas.microsoft.com/office/drawing/2016/SVG/main" r:embed="rId3"/>
+                <asvg:svgBlip xmlns:asvg="http://schemas.microsoft.com/office/drawing/2016/SVG/main" r:embed="rId2"/>
               </a:ext>
             </a:extLst>
           </a:blip>
@@ -3918,10 +3924,10 @@
           <p:nvPr/>
         </p:nvPicPr>
         <p:blipFill>
-          <a:blip r:embed="rId2">
+          <a:blip>
             <a:extLst>
               <a:ext uri="{96DAC541-7B7A-43D3-8B79-37D633B846F1}">
-                <asvg:svgBlip xmlns:asvg="http://schemas.microsoft.com/office/drawing/2016/SVG/main" r:embed="rId3"/>
+                <asvg:svgBlip xmlns:asvg="http://schemas.microsoft.com/office/drawing/2016/SVG/main" r:embed="rId2"/>
               </a:ext>
             </a:extLst>
           </a:blip>
@@ -3954,10 +3960,10 @@
           <p:nvPr/>
         </p:nvPicPr>
         <p:blipFill>
-          <a:blip r:embed="rId2">
+          <a:blip>
             <a:extLst>
               <a:ext uri="{96DAC541-7B7A-43D3-8B79-37D633B846F1}">
-                <asvg:svgBlip xmlns:asvg="http://schemas.microsoft.com/office/drawing/2016/SVG/main" r:embed="rId3"/>
+                <asvg:svgBlip xmlns:asvg="http://schemas.microsoft.com/office/drawing/2016/SVG/main" r:embed="rId2"/>
               </a:ext>
             </a:extLst>
           </a:blip>
@@ -3990,10 +3996,10 @@
           <p:nvPr/>
         </p:nvPicPr>
         <p:blipFill>
-          <a:blip r:embed="rId2">
+          <a:blip>
             <a:extLst>
               <a:ext uri="{96DAC541-7B7A-43D3-8B79-37D633B846F1}">
-                <asvg:svgBlip xmlns:asvg="http://schemas.microsoft.com/office/drawing/2016/SVG/main" r:embed="rId3"/>
+                <asvg:svgBlip xmlns:asvg="http://schemas.microsoft.com/office/drawing/2016/SVG/main" r:embed="rId2"/>
               </a:ext>
             </a:extLst>
           </a:blip>
@@ -5441,6 +5447,2033 @@
 </p:sld>
 </file>
 
+<file path=ppt/slides/slide11.xml><?xml version="1.0" encoding="utf-8"?>
+<p:sld xmlns:a="http://schemas.openxmlformats.org/drawingml/2006/main" xmlns:r="http://schemas.openxmlformats.org/officeDocument/2006/relationships" xmlns:p="http://schemas.openxmlformats.org/presentationml/2006/main">
+  <p:cSld>
+    <p:spTree>
+      <p:nvGrpSpPr>
+        <p:cNvPr id="1" name="">
+          <a:extLst>
+            <a:ext uri="{FF2B5EF4-FFF2-40B4-BE49-F238E27FC236}">
+              <a16:creationId xmlns:a16="http://schemas.microsoft.com/office/drawing/2014/main" id="{50BEBE77-30C0-5B20-1E9A-3BE964E356B4}"/>
+            </a:ext>
+          </a:extLst>
+        </p:cNvPr>
+        <p:cNvGrpSpPr/>
+        <p:nvPr/>
+      </p:nvGrpSpPr>
+      <p:grpSpPr>
+        <a:xfrm>
+          <a:off x="0" y="0"/>
+          <a:ext cx="0" cy="0"/>
+          <a:chOff x="0" y="0"/>
+          <a:chExt cx="0" cy="0"/>
+        </a:xfrm>
+      </p:grpSpPr>
+      <p:grpSp>
+        <p:nvGrpSpPr>
+          <p:cNvPr id="138" name="Group 137">
+            <a:extLst>
+              <a:ext uri="{FF2B5EF4-FFF2-40B4-BE49-F238E27FC236}">
+                <a16:creationId xmlns:a16="http://schemas.microsoft.com/office/drawing/2014/main" id="{252892C3-7102-31E3-E7FD-21511D93D49B}"/>
+              </a:ext>
+            </a:extLst>
+          </p:cNvPr>
+          <p:cNvGrpSpPr/>
+          <p:nvPr/>
+        </p:nvGrpSpPr>
+        <p:grpSpPr>
+          <a:xfrm>
+            <a:off x="-2107451" y="542351"/>
+            <a:ext cx="18680649" cy="6495255"/>
+            <a:chOff x="-2107451" y="542351"/>
+            <a:chExt cx="18680649" cy="6495255"/>
+          </a:xfrm>
+        </p:grpSpPr>
+        <p:sp>
+          <p:nvSpPr>
+            <p:cNvPr id="27" name="Rounded Rectangle 26">
+              <a:extLst>
+                <a:ext uri="{FF2B5EF4-FFF2-40B4-BE49-F238E27FC236}">
+                  <a16:creationId xmlns:a16="http://schemas.microsoft.com/office/drawing/2014/main" id="{5A3D4948-6540-3BE4-0223-A2B3A2AAF9B4}"/>
+                </a:ext>
+              </a:extLst>
+            </p:cNvPr>
+            <p:cNvSpPr/>
+            <p:nvPr/>
+          </p:nvSpPr>
+          <p:spPr>
+            <a:xfrm>
+              <a:off x="3846199" y="1538877"/>
+              <a:ext cx="4529099" cy="630201"/>
+            </a:xfrm>
+            <a:prstGeom prst="roundRect">
+              <a:avLst>
+                <a:gd name="adj" fmla="val 50000"/>
+              </a:avLst>
+            </a:prstGeom>
+            <a:solidFill>
+              <a:schemeClr val="tx1">
+                <a:alpha val="5000"/>
+              </a:schemeClr>
+            </a:solidFill>
+            <a:ln w="31750">
+              <a:solidFill>
+                <a:schemeClr val="tx1"/>
+              </a:solidFill>
+            </a:ln>
+          </p:spPr>
+          <p:style>
+            <a:lnRef idx="2">
+              <a:schemeClr val="accent1">
+                <a:shade val="15000"/>
+              </a:schemeClr>
+            </a:lnRef>
+            <a:fillRef idx="1">
+              <a:schemeClr val="accent1"/>
+            </a:fillRef>
+            <a:effectRef idx="0">
+              <a:schemeClr val="accent1"/>
+            </a:effectRef>
+            <a:fontRef idx="minor">
+              <a:schemeClr val="lt1"/>
+            </a:fontRef>
+          </p:style>
+          <p:txBody>
+            <a:bodyPr rtlCol="0" anchor="ctr"/>
+            <a:lstStyle/>
+            <a:p>
+              <a:pPr algn="ctr"/>
+              <a:r>
+                <a:rPr lang="en-US" dirty="0">
+                  <a:solidFill>
+                    <a:schemeClr val="tx1"/>
+                  </a:solidFill>
+                </a:rPr>
+                <a:t>Q-learning Run (Trial 1)</a:t>
+              </a:r>
+            </a:p>
+          </p:txBody>
+        </p:sp>
+        <p:sp>
+          <p:nvSpPr>
+            <p:cNvPr id="2" name="Rounded Rectangle 1">
+              <a:extLst>
+                <a:ext uri="{FF2B5EF4-FFF2-40B4-BE49-F238E27FC236}">
+                  <a16:creationId xmlns:a16="http://schemas.microsoft.com/office/drawing/2014/main" id="{0B01D2B7-E1FB-48F0-119D-DB13DDDCE7AA}"/>
+                </a:ext>
+              </a:extLst>
+            </p:cNvPr>
+            <p:cNvSpPr/>
+            <p:nvPr/>
+          </p:nvSpPr>
+          <p:spPr>
+            <a:xfrm>
+              <a:off x="3846199" y="2407373"/>
+              <a:ext cx="4529099" cy="630201"/>
+            </a:xfrm>
+            <a:prstGeom prst="roundRect">
+              <a:avLst>
+                <a:gd name="adj" fmla="val 50000"/>
+              </a:avLst>
+            </a:prstGeom>
+            <a:solidFill>
+              <a:schemeClr val="tx1">
+                <a:alpha val="5000"/>
+              </a:schemeClr>
+            </a:solidFill>
+            <a:ln w="31750">
+              <a:solidFill>
+                <a:schemeClr val="tx1"/>
+              </a:solidFill>
+            </a:ln>
+          </p:spPr>
+          <p:style>
+            <a:lnRef idx="2">
+              <a:schemeClr val="accent1">
+                <a:shade val="15000"/>
+              </a:schemeClr>
+            </a:lnRef>
+            <a:fillRef idx="1">
+              <a:schemeClr val="accent1"/>
+            </a:fillRef>
+            <a:effectRef idx="0">
+              <a:schemeClr val="accent1"/>
+            </a:effectRef>
+            <a:fontRef idx="minor">
+              <a:schemeClr val="lt1"/>
+            </a:fontRef>
+          </p:style>
+          <p:txBody>
+            <a:bodyPr rtlCol="0" anchor="ctr"/>
+            <a:lstStyle/>
+            <a:p>
+              <a:pPr algn="ctr"/>
+              <a:r>
+                <a:rPr lang="en-US" dirty="0">
+                  <a:solidFill>
+                    <a:schemeClr val="tx1"/>
+                  </a:solidFill>
+                </a:rPr>
+                <a:t>Q-learning Run (Trial 2)</a:t>
+              </a:r>
+            </a:p>
+          </p:txBody>
+        </p:sp>
+        <p:sp>
+          <p:nvSpPr>
+            <p:cNvPr id="3" name="Rounded Rectangle 2">
+              <a:extLst>
+                <a:ext uri="{FF2B5EF4-FFF2-40B4-BE49-F238E27FC236}">
+                  <a16:creationId xmlns:a16="http://schemas.microsoft.com/office/drawing/2014/main" id="{1E2C0CB7-3EF0-BEC2-018A-2672FB8FDEC8}"/>
+                </a:ext>
+              </a:extLst>
+            </p:cNvPr>
+            <p:cNvSpPr/>
+            <p:nvPr/>
+          </p:nvSpPr>
+          <p:spPr>
+            <a:xfrm>
+              <a:off x="3846199" y="3275869"/>
+              <a:ext cx="4529099" cy="630201"/>
+            </a:xfrm>
+            <a:prstGeom prst="roundRect">
+              <a:avLst>
+                <a:gd name="adj" fmla="val 50000"/>
+              </a:avLst>
+            </a:prstGeom>
+            <a:solidFill>
+              <a:schemeClr val="tx1">
+                <a:alpha val="5000"/>
+              </a:schemeClr>
+            </a:solidFill>
+            <a:ln w="31750">
+              <a:solidFill>
+                <a:schemeClr val="tx1"/>
+              </a:solidFill>
+            </a:ln>
+          </p:spPr>
+          <p:style>
+            <a:lnRef idx="2">
+              <a:schemeClr val="accent1">
+                <a:shade val="15000"/>
+              </a:schemeClr>
+            </a:lnRef>
+            <a:fillRef idx="1">
+              <a:schemeClr val="accent1"/>
+            </a:fillRef>
+            <a:effectRef idx="0">
+              <a:schemeClr val="accent1"/>
+            </a:effectRef>
+            <a:fontRef idx="minor">
+              <a:schemeClr val="lt1"/>
+            </a:fontRef>
+          </p:style>
+          <p:txBody>
+            <a:bodyPr rtlCol="0" anchor="ctr"/>
+            <a:lstStyle/>
+            <a:p>
+              <a:pPr algn="ctr"/>
+              <a:r>
+                <a:rPr lang="en-US" dirty="0">
+                  <a:solidFill>
+                    <a:schemeClr val="tx1"/>
+                  </a:solidFill>
+                </a:rPr>
+                <a:t>Q-learning Run (Trial 3)</a:t>
+              </a:r>
+            </a:p>
+          </p:txBody>
+        </p:sp>
+        <p:sp>
+          <p:nvSpPr>
+            <p:cNvPr id="4" name="Rounded Rectangle 3">
+              <a:extLst>
+                <a:ext uri="{FF2B5EF4-FFF2-40B4-BE49-F238E27FC236}">
+                  <a16:creationId xmlns:a16="http://schemas.microsoft.com/office/drawing/2014/main" id="{0842825A-4A5C-46F3-FF5C-CB85630F2F59}"/>
+                </a:ext>
+              </a:extLst>
+            </p:cNvPr>
+            <p:cNvSpPr/>
+            <p:nvPr/>
+          </p:nvSpPr>
+          <p:spPr>
+            <a:xfrm>
+              <a:off x="3846197" y="5201289"/>
+              <a:ext cx="4529099" cy="630201"/>
+            </a:xfrm>
+            <a:prstGeom prst="roundRect">
+              <a:avLst>
+                <a:gd name="adj" fmla="val 50000"/>
+              </a:avLst>
+            </a:prstGeom>
+            <a:solidFill>
+              <a:schemeClr val="tx1">
+                <a:alpha val="5000"/>
+              </a:schemeClr>
+            </a:solidFill>
+            <a:ln w="31750">
+              <a:solidFill>
+                <a:schemeClr val="tx1"/>
+              </a:solidFill>
+            </a:ln>
+          </p:spPr>
+          <p:style>
+            <a:lnRef idx="2">
+              <a:schemeClr val="accent1">
+                <a:shade val="15000"/>
+              </a:schemeClr>
+            </a:lnRef>
+            <a:fillRef idx="1">
+              <a:schemeClr val="accent1"/>
+            </a:fillRef>
+            <a:effectRef idx="0">
+              <a:schemeClr val="accent1"/>
+            </a:effectRef>
+            <a:fontRef idx="minor">
+              <a:schemeClr val="lt1"/>
+            </a:fontRef>
+          </p:style>
+          <p:txBody>
+            <a:bodyPr rtlCol="0" anchor="ctr"/>
+            <a:lstStyle/>
+            <a:p>
+              <a:pPr algn="ctr"/>
+              <a:r>
+                <a:rPr lang="en-US" dirty="0">
+                  <a:solidFill>
+                    <a:schemeClr val="tx1"/>
+                  </a:solidFill>
+                </a:rPr>
+                <a:t>Q-learning Run (Trial N)</a:t>
+              </a:r>
+            </a:p>
+          </p:txBody>
+        </p:sp>
+        <p:sp>
+          <p:nvSpPr>
+            <p:cNvPr id="5" name="Rounded Rectangle 4">
+              <a:extLst>
+                <a:ext uri="{FF2B5EF4-FFF2-40B4-BE49-F238E27FC236}">
+                  <a16:creationId xmlns:a16="http://schemas.microsoft.com/office/drawing/2014/main" id="{C4D8587E-7E3D-471C-5550-1C5CC78AF7BF}"/>
+                </a:ext>
+              </a:extLst>
+            </p:cNvPr>
+            <p:cNvSpPr/>
+            <p:nvPr/>
+          </p:nvSpPr>
+          <p:spPr>
+            <a:xfrm>
+              <a:off x="617005" y="2509378"/>
+              <a:ext cx="1733320" cy="2163182"/>
+            </a:xfrm>
+            <a:prstGeom prst="roundRect">
+              <a:avLst>
+                <a:gd name="adj" fmla="val 50000"/>
+              </a:avLst>
+            </a:prstGeom>
+            <a:solidFill>
+              <a:schemeClr val="tx1">
+                <a:alpha val="5000"/>
+              </a:schemeClr>
+            </a:solidFill>
+            <a:ln w="31750">
+              <a:solidFill>
+                <a:schemeClr val="tx1"/>
+              </a:solidFill>
+            </a:ln>
+          </p:spPr>
+          <p:style>
+            <a:lnRef idx="2">
+              <a:schemeClr val="accent1">
+                <a:shade val="15000"/>
+              </a:schemeClr>
+            </a:lnRef>
+            <a:fillRef idx="1">
+              <a:schemeClr val="accent1"/>
+            </a:fillRef>
+            <a:effectRef idx="0">
+              <a:schemeClr val="accent1"/>
+            </a:effectRef>
+            <a:fontRef idx="minor">
+              <a:schemeClr val="lt1"/>
+            </a:fontRef>
+          </p:style>
+          <p:txBody>
+            <a:bodyPr rtlCol="0" anchor="ctr"/>
+            <a:lstStyle/>
+            <a:p>
+              <a:pPr algn="ctr"/>
+              <a:r>
+                <a:rPr lang="en-US" dirty="0" err="1">
+                  <a:solidFill>
+                    <a:schemeClr val="tx1"/>
+                  </a:solidFill>
+                </a:rPr>
+                <a:t>Initialise</a:t>
+              </a:r>
+              <a:r>
+                <a:rPr lang="en-US" dirty="0">
+                  <a:solidFill>
+                    <a:schemeClr val="tx1"/>
+                  </a:solidFill>
+                </a:rPr>
+                <a:t> Q-values </a:t>
+              </a:r>
+            </a:p>
+          </p:txBody>
+        </p:sp>
+        <p:sp>
+          <p:nvSpPr>
+            <p:cNvPr id="6" name="Rounded Rectangle 5">
+              <a:extLst>
+                <a:ext uri="{FF2B5EF4-FFF2-40B4-BE49-F238E27FC236}">
+                  <a16:creationId xmlns:a16="http://schemas.microsoft.com/office/drawing/2014/main" id="{974C4A6E-E954-52B6-83C9-E16E390C4647}"/>
+                </a:ext>
+              </a:extLst>
+            </p:cNvPr>
+            <p:cNvSpPr/>
+            <p:nvPr/>
+          </p:nvSpPr>
+          <p:spPr>
+            <a:xfrm>
+              <a:off x="9871172" y="2509378"/>
+              <a:ext cx="1733320" cy="2163182"/>
+            </a:xfrm>
+            <a:prstGeom prst="roundRect">
+              <a:avLst>
+                <a:gd name="adj" fmla="val 50000"/>
+              </a:avLst>
+            </a:prstGeom>
+            <a:solidFill>
+              <a:schemeClr val="tx1">
+                <a:alpha val="5000"/>
+              </a:schemeClr>
+            </a:solidFill>
+            <a:ln w="31750">
+              <a:solidFill>
+                <a:schemeClr val="tx1"/>
+              </a:solidFill>
+            </a:ln>
+          </p:spPr>
+          <p:style>
+            <a:lnRef idx="2">
+              <a:schemeClr val="accent1">
+                <a:shade val="15000"/>
+              </a:schemeClr>
+            </a:lnRef>
+            <a:fillRef idx="1">
+              <a:schemeClr val="accent1"/>
+            </a:fillRef>
+            <a:effectRef idx="0">
+              <a:schemeClr val="accent1"/>
+            </a:effectRef>
+            <a:fontRef idx="minor">
+              <a:schemeClr val="lt1"/>
+            </a:fontRef>
+          </p:style>
+          <p:txBody>
+            <a:bodyPr rtlCol="0" anchor="ctr"/>
+            <a:lstStyle/>
+            <a:p>
+              <a:pPr algn="ctr"/>
+              <a:r>
+                <a:rPr lang="en-US" dirty="0">
+                  <a:solidFill>
+                    <a:schemeClr val="tx1"/>
+                  </a:solidFill>
+                </a:rPr>
+                <a:t>Combine Q-values</a:t>
+              </a:r>
+            </a:p>
+          </p:txBody>
+        </p:sp>
+        <p:sp>
+          <p:nvSpPr>
+            <p:cNvPr id="19" name="Oval 18">
+              <a:extLst>
+                <a:ext uri="{FF2B5EF4-FFF2-40B4-BE49-F238E27FC236}">
+                  <a16:creationId xmlns:a16="http://schemas.microsoft.com/office/drawing/2014/main" id="{9BA6AA1E-3ACC-D0F1-B73E-04458C566F85}"/>
+                </a:ext>
+              </a:extLst>
+            </p:cNvPr>
+            <p:cNvSpPr/>
+            <p:nvPr/>
+          </p:nvSpPr>
+          <p:spPr>
+            <a:xfrm>
+              <a:off x="2229139" y="3527162"/>
+              <a:ext cx="121186" cy="127613"/>
+            </a:xfrm>
+            <a:prstGeom prst="ellipse">
+              <a:avLst/>
+            </a:prstGeom>
+            <a:noFill/>
+            <a:ln>
+              <a:noFill/>
+            </a:ln>
+          </p:spPr>
+          <p:style>
+            <a:lnRef idx="2">
+              <a:schemeClr val="accent1">
+                <a:shade val="15000"/>
+              </a:schemeClr>
+            </a:lnRef>
+            <a:fillRef idx="1">
+              <a:schemeClr val="accent1"/>
+            </a:fillRef>
+            <a:effectRef idx="0">
+              <a:schemeClr val="accent1"/>
+            </a:effectRef>
+            <a:fontRef idx="minor">
+              <a:schemeClr val="lt1"/>
+            </a:fontRef>
+          </p:style>
+          <p:txBody>
+            <a:bodyPr rtlCol="0" anchor="ctr"/>
+            <a:lstStyle/>
+            <a:p>
+              <a:pPr algn="ctr"/>
+              <a:endParaRPr lang="en-US"/>
+            </a:p>
+          </p:txBody>
+        </p:sp>
+        <p:sp>
+          <p:nvSpPr>
+            <p:cNvPr id="20" name="Oval 19">
+              <a:extLst>
+                <a:ext uri="{FF2B5EF4-FFF2-40B4-BE49-F238E27FC236}">
+                  <a16:creationId xmlns:a16="http://schemas.microsoft.com/office/drawing/2014/main" id="{F503C4E6-B51D-C75C-4F8F-8EA29B56C7F1}"/>
+                </a:ext>
+              </a:extLst>
+            </p:cNvPr>
+            <p:cNvSpPr/>
+            <p:nvPr/>
+          </p:nvSpPr>
+          <p:spPr>
+            <a:xfrm>
+              <a:off x="2229139" y="3360907"/>
+              <a:ext cx="121186" cy="127613"/>
+            </a:xfrm>
+            <a:prstGeom prst="ellipse">
+              <a:avLst/>
+            </a:prstGeom>
+            <a:noFill/>
+            <a:ln>
+              <a:noFill/>
+            </a:ln>
+          </p:spPr>
+          <p:style>
+            <a:lnRef idx="2">
+              <a:schemeClr val="accent1">
+                <a:shade val="15000"/>
+              </a:schemeClr>
+            </a:lnRef>
+            <a:fillRef idx="1">
+              <a:schemeClr val="accent1"/>
+            </a:fillRef>
+            <a:effectRef idx="0">
+              <a:schemeClr val="accent1"/>
+            </a:effectRef>
+            <a:fontRef idx="minor">
+              <a:schemeClr val="lt1"/>
+            </a:fontRef>
+          </p:style>
+          <p:txBody>
+            <a:bodyPr rtlCol="0" anchor="ctr"/>
+            <a:lstStyle/>
+            <a:p>
+              <a:pPr algn="ctr"/>
+              <a:endParaRPr lang="en-US"/>
+            </a:p>
+          </p:txBody>
+        </p:sp>
+        <p:sp>
+          <p:nvSpPr>
+            <p:cNvPr id="21" name="Oval 20">
+              <a:extLst>
+                <a:ext uri="{FF2B5EF4-FFF2-40B4-BE49-F238E27FC236}">
+                  <a16:creationId xmlns:a16="http://schemas.microsoft.com/office/drawing/2014/main" id="{60FCBD5F-83CF-5273-09FA-3D488C28384F}"/>
+                </a:ext>
+              </a:extLst>
+            </p:cNvPr>
+            <p:cNvSpPr/>
+            <p:nvPr/>
+          </p:nvSpPr>
+          <p:spPr>
+            <a:xfrm>
+              <a:off x="2229139" y="3194652"/>
+              <a:ext cx="121186" cy="127613"/>
+            </a:xfrm>
+            <a:prstGeom prst="ellipse">
+              <a:avLst/>
+            </a:prstGeom>
+            <a:noFill/>
+            <a:ln>
+              <a:noFill/>
+            </a:ln>
+          </p:spPr>
+          <p:style>
+            <a:lnRef idx="2">
+              <a:schemeClr val="accent1">
+                <a:shade val="15000"/>
+              </a:schemeClr>
+            </a:lnRef>
+            <a:fillRef idx="1">
+              <a:schemeClr val="accent1"/>
+            </a:fillRef>
+            <a:effectRef idx="0">
+              <a:schemeClr val="accent1"/>
+            </a:effectRef>
+            <a:fontRef idx="minor">
+              <a:schemeClr val="lt1"/>
+            </a:fontRef>
+          </p:style>
+          <p:txBody>
+            <a:bodyPr rtlCol="0" anchor="ctr"/>
+            <a:lstStyle/>
+            <a:p>
+              <a:pPr algn="ctr"/>
+              <a:endParaRPr lang="en-US"/>
+            </a:p>
+          </p:txBody>
+        </p:sp>
+        <p:sp>
+          <p:nvSpPr>
+            <p:cNvPr id="22" name="Oval 21">
+              <a:extLst>
+                <a:ext uri="{FF2B5EF4-FFF2-40B4-BE49-F238E27FC236}">
+                  <a16:creationId xmlns:a16="http://schemas.microsoft.com/office/drawing/2014/main" id="{81CA5405-7390-5734-DB7A-DA362BB59C54}"/>
+                </a:ext>
+              </a:extLst>
+            </p:cNvPr>
+            <p:cNvSpPr/>
+            <p:nvPr/>
+          </p:nvSpPr>
+          <p:spPr>
+            <a:xfrm>
+              <a:off x="2229139" y="3693417"/>
+              <a:ext cx="121186" cy="127613"/>
+            </a:xfrm>
+            <a:prstGeom prst="ellipse">
+              <a:avLst/>
+            </a:prstGeom>
+            <a:noFill/>
+            <a:ln>
+              <a:noFill/>
+            </a:ln>
+          </p:spPr>
+          <p:style>
+            <a:lnRef idx="2">
+              <a:schemeClr val="accent1">
+                <a:shade val="15000"/>
+              </a:schemeClr>
+            </a:lnRef>
+            <a:fillRef idx="1">
+              <a:schemeClr val="accent1"/>
+            </a:fillRef>
+            <a:effectRef idx="0">
+              <a:schemeClr val="accent1"/>
+            </a:effectRef>
+            <a:fontRef idx="minor">
+              <a:schemeClr val="lt1"/>
+            </a:fontRef>
+          </p:style>
+          <p:txBody>
+            <a:bodyPr rtlCol="0" anchor="ctr"/>
+            <a:lstStyle/>
+            <a:p>
+              <a:pPr algn="ctr"/>
+              <a:endParaRPr lang="en-US"/>
+            </a:p>
+          </p:txBody>
+        </p:sp>
+        <p:sp>
+          <p:nvSpPr>
+            <p:cNvPr id="23" name="Oval 22">
+              <a:extLst>
+                <a:ext uri="{FF2B5EF4-FFF2-40B4-BE49-F238E27FC236}">
+                  <a16:creationId xmlns:a16="http://schemas.microsoft.com/office/drawing/2014/main" id="{609AC17E-A531-8E12-A7D2-D1400EBDB5A2}"/>
+                </a:ext>
+              </a:extLst>
+            </p:cNvPr>
+            <p:cNvSpPr/>
+            <p:nvPr/>
+          </p:nvSpPr>
+          <p:spPr>
+            <a:xfrm>
+              <a:off x="2229139" y="3859672"/>
+              <a:ext cx="121186" cy="127613"/>
+            </a:xfrm>
+            <a:prstGeom prst="ellipse">
+              <a:avLst/>
+            </a:prstGeom>
+            <a:noFill/>
+            <a:ln>
+              <a:noFill/>
+            </a:ln>
+          </p:spPr>
+          <p:style>
+            <a:lnRef idx="2">
+              <a:schemeClr val="accent1">
+                <a:shade val="15000"/>
+              </a:schemeClr>
+            </a:lnRef>
+            <a:fillRef idx="1">
+              <a:schemeClr val="accent1"/>
+            </a:fillRef>
+            <a:effectRef idx="0">
+              <a:schemeClr val="accent1"/>
+            </a:effectRef>
+            <a:fontRef idx="minor">
+              <a:schemeClr val="lt1"/>
+            </a:fontRef>
+          </p:style>
+          <p:txBody>
+            <a:bodyPr rtlCol="0" anchor="ctr"/>
+            <a:lstStyle/>
+            <a:p>
+              <a:pPr algn="ctr"/>
+              <a:endParaRPr lang="en-US"/>
+            </a:p>
+          </p:txBody>
+        </p:sp>
+        <p:cxnSp>
+          <p:nvCxnSpPr>
+            <p:cNvPr id="25" name="Curved Connector 24">
+              <a:extLst>
+                <a:ext uri="{FF2B5EF4-FFF2-40B4-BE49-F238E27FC236}">
+                  <a16:creationId xmlns:a16="http://schemas.microsoft.com/office/drawing/2014/main" id="{810AA933-1E94-E208-3997-F3C47F45BBED}"/>
+                </a:ext>
+              </a:extLst>
+            </p:cNvPr>
+            <p:cNvCxnSpPr>
+              <a:cxnSpLocks/>
+              <a:stCxn id="21" idx="6"/>
+              <a:endCxn id="27" idx="1"/>
+            </p:cNvCxnSpPr>
+            <p:nvPr/>
+          </p:nvCxnSpPr>
+          <p:spPr>
+            <a:xfrm flipV="1">
+              <a:off x="2350325" y="1853978"/>
+              <a:ext cx="1495874" cy="1404481"/>
+            </a:xfrm>
+            <a:prstGeom prst="curvedConnector3">
+              <a:avLst/>
+            </a:prstGeom>
+            <a:ln w="28575">
+              <a:solidFill>
+                <a:schemeClr val="tx1"/>
+              </a:solidFill>
+              <a:tailEnd type="triangle" w="lg" len="lg"/>
+            </a:ln>
+          </p:spPr>
+          <p:style>
+            <a:lnRef idx="2">
+              <a:schemeClr val="accent1"/>
+            </a:lnRef>
+            <a:fillRef idx="0">
+              <a:schemeClr val="accent1"/>
+            </a:fillRef>
+            <a:effectRef idx="1">
+              <a:schemeClr val="accent1"/>
+            </a:effectRef>
+            <a:fontRef idx="minor">
+              <a:schemeClr val="tx1"/>
+            </a:fontRef>
+          </p:style>
+        </p:cxnSp>
+        <p:cxnSp>
+          <p:nvCxnSpPr>
+            <p:cNvPr id="47" name="Curved Connector 46">
+              <a:extLst>
+                <a:ext uri="{FF2B5EF4-FFF2-40B4-BE49-F238E27FC236}">
+                  <a16:creationId xmlns:a16="http://schemas.microsoft.com/office/drawing/2014/main" id="{1AC11EB6-9E1E-3AE5-FF59-B840FB7C704E}"/>
+                </a:ext>
+              </a:extLst>
+            </p:cNvPr>
+            <p:cNvCxnSpPr>
+              <a:cxnSpLocks/>
+              <a:stCxn id="20" idx="6"/>
+              <a:endCxn id="2" idx="1"/>
+            </p:cNvCxnSpPr>
+            <p:nvPr/>
+          </p:nvCxnSpPr>
+          <p:spPr>
+            <a:xfrm flipV="1">
+              <a:off x="2350325" y="2722474"/>
+              <a:ext cx="1495874" cy="702240"/>
+            </a:xfrm>
+            <a:prstGeom prst="curvedConnector3">
+              <a:avLst/>
+            </a:prstGeom>
+            <a:ln w="28575">
+              <a:solidFill>
+                <a:schemeClr val="tx1"/>
+              </a:solidFill>
+              <a:tailEnd type="triangle" w="lg" len="lg"/>
+            </a:ln>
+          </p:spPr>
+          <p:style>
+            <a:lnRef idx="2">
+              <a:schemeClr val="accent1"/>
+            </a:lnRef>
+            <a:fillRef idx="0">
+              <a:schemeClr val="accent1"/>
+            </a:fillRef>
+            <a:effectRef idx="1">
+              <a:schemeClr val="accent1"/>
+            </a:effectRef>
+            <a:fontRef idx="minor">
+              <a:schemeClr val="tx1"/>
+            </a:fontRef>
+          </p:style>
+        </p:cxnSp>
+        <p:cxnSp>
+          <p:nvCxnSpPr>
+            <p:cNvPr id="50" name="Curved Connector 49">
+              <a:extLst>
+                <a:ext uri="{FF2B5EF4-FFF2-40B4-BE49-F238E27FC236}">
+                  <a16:creationId xmlns:a16="http://schemas.microsoft.com/office/drawing/2014/main" id="{ECE467B1-8D7B-742F-CFF5-7990618220CB}"/>
+                </a:ext>
+              </a:extLst>
+            </p:cNvPr>
+            <p:cNvCxnSpPr>
+              <a:cxnSpLocks/>
+              <a:stCxn id="19" idx="6"/>
+              <a:endCxn id="3" idx="1"/>
+            </p:cNvCxnSpPr>
+            <p:nvPr/>
+          </p:nvCxnSpPr>
+          <p:spPr>
+            <a:xfrm>
+              <a:off x="2350325" y="3590969"/>
+              <a:ext cx="1495874" cy="1"/>
+            </a:xfrm>
+            <a:prstGeom prst="curvedConnector3">
+              <a:avLst/>
+            </a:prstGeom>
+            <a:ln w="28575">
+              <a:solidFill>
+                <a:schemeClr val="tx1"/>
+              </a:solidFill>
+              <a:tailEnd type="triangle" w="lg" len="lg"/>
+            </a:ln>
+          </p:spPr>
+          <p:style>
+            <a:lnRef idx="2">
+              <a:schemeClr val="accent1"/>
+            </a:lnRef>
+            <a:fillRef idx="0">
+              <a:schemeClr val="accent1"/>
+            </a:fillRef>
+            <a:effectRef idx="1">
+              <a:schemeClr val="accent1"/>
+            </a:effectRef>
+            <a:fontRef idx="minor">
+              <a:schemeClr val="tx1"/>
+            </a:fontRef>
+          </p:style>
+        </p:cxnSp>
+        <p:cxnSp>
+          <p:nvCxnSpPr>
+            <p:cNvPr id="53" name="Curved Connector 52">
+              <a:extLst>
+                <a:ext uri="{FF2B5EF4-FFF2-40B4-BE49-F238E27FC236}">
+                  <a16:creationId xmlns:a16="http://schemas.microsoft.com/office/drawing/2014/main" id="{F992F059-3A78-FEF1-0600-F8A688D01EDA}"/>
+                </a:ext>
+              </a:extLst>
+            </p:cNvPr>
+            <p:cNvCxnSpPr>
+              <a:cxnSpLocks/>
+              <a:stCxn id="23" idx="6"/>
+              <a:endCxn id="4" idx="1"/>
+            </p:cNvCxnSpPr>
+            <p:nvPr/>
+          </p:nvCxnSpPr>
+          <p:spPr>
+            <a:xfrm>
+              <a:off x="2350325" y="3923479"/>
+              <a:ext cx="1495872" cy="1592911"/>
+            </a:xfrm>
+            <a:prstGeom prst="curvedConnector3">
+              <a:avLst>
+                <a:gd name="adj1" fmla="val 50000"/>
+              </a:avLst>
+            </a:prstGeom>
+            <a:ln w="28575">
+              <a:solidFill>
+                <a:schemeClr val="tx1"/>
+              </a:solidFill>
+              <a:tailEnd type="triangle" w="lg" len="lg"/>
+            </a:ln>
+          </p:spPr>
+          <p:style>
+            <a:lnRef idx="2">
+              <a:schemeClr val="accent1"/>
+            </a:lnRef>
+            <a:fillRef idx="0">
+              <a:schemeClr val="accent1"/>
+            </a:fillRef>
+            <a:effectRef idx="1">
+              <a:schemeClr val="accent1"/>
+            </a:effectRef>
+            <a:fontRef idx="minor">
+              <a:schemeClr val="tx1"/>
+            </a:fontRef>
+          </p:style>
+        </p:cxnSp>
+        <p:cxnSp>
+          <p:nvCxnSpPr>
+            <p:cNvPr id="59" name="Curved Connector 58">
+              <a:extLst>
+                <a:ext uri="{FF2B5EF4-FFF2-40B4-BE49-F238E27FC236}">
+                  <a16:creationId xmlns:a16="http://schemas.microsoft.com/office/drawing/2014/main" id="{8F583267-CA37-1EE8-73FA-CFBAD90443A5}"/>
+                </a:ext>
+              </a:extLst>
+            </p:cNvPr>
+            <p:cNvCxnSpPr>
+              <a:cxnSpLocks/>
+              <a:stCxn id="22" idx="6"/>
+            </p:cNvCxnSpPr>
+            <p:nvPr/>
+          </p:nvCxnSpPr>
+          <p:spPr>
+            <a:xfrm>
+              <a:off x="2350325" y="3757224"/>
+              <a:ext cx="1495873" cy="796456"/>
+            </a:xfrm>
+            <a:prstGeom prst="curvedConnector3">
+              <a:avLst>
+                <a:gd name="adj1" fmla="val 50000"/>
+              </a:avLst>
+            </a:prstGeom>
+            <a:ln w="28575">
+              <a:solidFill>
+                <a:schemeClr val="tx1"/>
+              </a:solidFill>
+              <a:tailEnd type="triangle" w="lg" len="lg"/>
+            </a:ln>
+          </p:spPr>
+          <p:style>
+            <a:lnRef idx="2">
+              <a:schemeClr val="accent1"/>
+            </a:lnRef>
+            <a:fillRef idx="0">
+              <a:schemeClr val="accent1"/>
+            </a:fillRef>
+            <a:effectRef idx="1">
+              <a:schemeClr val="accent1"/>
+            </a:effectRef>
+            <a:fontRef idx="minor">
+              <a:schemeClr val="tx1"/>
+            </a:fontRef>
+          </p:style>
+        </p:cxnSp>
+        <p:sp>
+          <p:nvSpPr>
+            <p:cNvPr id="67" name="Oval 66">
+              <a:extLst>
+                <a:ext uri="{FF2B5EF4-FFF2-40B4-BE49-F238E27FC236}">
+                  <a16:creationId xmlns:a16="http://schemas.microsoft.com/office/drawing/2014/main" id="{C24AE7C2-820C-A172-A508-DEC48E937AEE}"/>
+                </a:ext>
+              </a:extLst>
+            </p:cNvPr>
+            <p:cNvSpPr/>
+            <p:nvPr/>
+          </p:nvSpPr>
+          <p:spPr>
+            <a:xfrm>
+              <a:off x="9871170" y="3527162"/>
+              <a:ext cx="121186" cy="127613"/>
+            </a:xfrm>
+            <a:prstGeom prst="ellipse">
+              <a:avLst/>
+            </a:prstGeom>
+            <a:noFill/>
+            <a:ln>
+              <a:noFill/>
+            </a:ln>
+          </p:spPr>
+          <p:style>
+            <a:lnRef idx="2">
+              <a:schemeClr val="accent1">
+                <a:shade val="15000"/>
+              </a:schemeClr>
+            </a:lnRef>
+            <a:fillRef idx="1">
+              <a:schemeClr val="accent1"/>
+            </a:fillRef>
+            <a:effectRef idx="0">
+              <a:schemeClr val="accent1"/>
+            </a:effectRef>
+            <a:fontRef idx="minor">
+              <a:schemeClr val="lt1"/>
+            </a:fontRef>
+          </p:style>
+          <p:txBody>
+            <a:bodyPr rtlCol="0" anchor="ctr"/>
+            <a:lstStyle/>
+            <a:p>
+              <a:pPr algn="ctr"/>
+              <a:endParaRPr lang="en-US"/>
+            </a:p>
+          </p:txBody>
+        </p:sp>
+        <p:sp>
+          <p:nvSpPr>
+            <p:cNvPr id="68" name="Oval 67">
+              <a:extLst>
+                <a:ext uri="{FF2B5EF4-FFF2-40B4-BE49-F238E27FC236}">
+                  <a16:creationId xmlns:a16="http://schemas.microsoft.com/office/drawing/2014/main" id="{B3C00BED-EC99-6EB0-9825-483934BC5A51}"/>
+                </a:ext>
+              </a:extLst>
+            </p:cNvPr>
+            <p:cNvSpPr/>
+            <p:nvPr/>
+          </p:nvSpPr>
+          <p:spPr>
+            <a:xfrm>
+              <a:off x="9871170" y="3360907"/>
+              <a:ext cx="121186" cy="127613"/>
+            </a:xfrm>
+            <a:prstGeom prst="ellipse">
+              <a:avLst/>
+            </a:prstGeom>
+            <a:noFill/>
+            <a:ln>
+              <a:noFill/>
+            </a:ln>
+          </p:spPr>
+          <p:style>
+            <a:lnRef idx="2">
+              <a:schemeClr val="accent1">
+                <a:shade val="15000"/>
+              </a:schemeClr>
+            </a:lnRef>
+            <a:fillRef idx="1">
+              <a:schemeClr val="accent1"/>
+            </a:fillRef>
+            <a:effectRef idx="0">
+              <a:schemeClr val="accent1"/>
+            </a:effectRef>
+            <a:fontRef idx="minor">
+              <a:schemeClr val="lt1"/>
+            </a:fontRef>
+          </p:style>
+          <p:txBody>
+            <a:bodyPr rtlCol="0" anchor="ctr"/>
+            <a:lstStyle/>
+            <a:p>
+              <a:pPr algn="ctr"/>
+              <a:endParaRPr lang="en-US"/>
+            </a:p>
+          </p:txBody>
+        </p:sp>
+        <p:sp>
+          <p:nvSpPr>
+            <p:cNvPr id="69" name="Oval 68">
+              <a:extLst>
+                <a:ext uri="{FF2B5EF4-FFF2-40B4-BE49-F238E27FC236}">
+                  <a16:creationId xmlns:a16="http://schemas.microsoft.com/office/drawing/2014/main" id="{D2C1D03F-8377-7928-95EE-110A29677235}"/>
+                </a:ext>
+              </a:extLst>
+            </p:cNvPr>
+            <p:cNvSpPr/>
+            <p:nvPr/>
+          </p:nvSpPr>
+          <p:spPr>
+            <a:xfrm>
+              <a:off x="9871170" y="3194652"/>
+              <a:ext cx="121186" cy="127613"/>
+            </a:xfrm>
+            <a:prstGeom prst="ellipse">
+              <a:avLst/>
+            </a:prstGeom>
+            <a:noFill/>
+            <a:ln>
+              <a:noFill/>
+            </a:ln>
+          </p:spPr>
+          <p:style>
+            <a:lnRef idx="2">
+              <a:schemeClr val="accent1">
+                <a:shade val="15000"/>
+              </a:schemeClr>
+            </a:lnRef>
+            <a:fillRef idx="1">
+              <a:schemeClr val="accent1"/>
+            </a:fillRef>
+            <a:effectRef idx="0">
+              <a:schemeClr val="accent1"/>
+            </a:effectRef>
+            <a:fontRef idx="minor">
+              <a:schemeClr val="lt1"/>
+            </a:fontRef>
+          </p:style>
+          <p:txBody>
+            <a:bodyPr rtlCol="0" anchor="ctr"/>
+            <a:lstStyle/>
+            <a:p>
+              <a:pPr algn="ctr"/>
+              <a:endParaRPr lang="en-US"/>
+            </a:p>
+          </p:txBody>
+        </p:sp>
+        <p:sp>
+          <p:nvSpPr>
+            <p:cNvPr id="70" name="Oval 69">
+              <a:extLst>
+                <a:ext uri="{FF2B5EF4-FFF2-40B4-BE49-F238E27FC236}">
+                  <a16:creationId xmlns:a16="http://schemas.microsoft.com/office/drawing/2014/main" id="{A38E33BD-FA8C-96CF-6122-8CC7EF25DD16}"/>
+                </a:ext>
+              </a:extLst>
+            </p:cNvPr>
+            <p:cNvSpPr/>
+            <p:nvPr/>
+          </p:nvSpPr>
+          <p:spPr>
+            <a:xfrm>
+              <a:off x="9871170" y="3693417"/>
+              <a:ext cx="121186" cy="127613"/>
+            </a:xfrm>
+            <a:prstGeom prst="ellipse">
+              <a:avLst/>
+            </a:prstGeom>
+            <a:noFill/>
+            <a:ln>
+              <a:noFill/>
+            </a:ln>
+          </p:spPr>
+          <p:style>
+            <a:lnRef idx="2">
+              <a:schemeClr val="accent1">
+                <a:shade val="15000"/>
+              </a:schemeClr>
+            </a:lnRef>
+            <a:fillRef idx="1">
+              <a:schemeClr val="accent1"/>
+            </a:fillRef>
+            <a:effectRef idx="0">
+              <a:schemeClr val="accent1"/>
+            </a:effectRef>
+            <a:fontRef idx="minor">
+              <a:schemeClr val="lt1"/>
+            </a:fontRef>
+          </p:style>
+          <p:txBody>
+            <a:bodyPr rtlCol="0" anchor="ctr"/>
+            <a:lstStyle/>
+            <a:p>
+              <a:pPr algn="ctr"/>
+              <a:endParaRPr lang="en-US"/>
+            </a:p>
+          </p:txBody>
+        </p:sp>
+        <p:sp>
+          <p:nvSpPr>
+            <p:cNvPr id="71" name="Oval 70">
+              <a:extLst>
+                <a:ext uri="{FF2B5EF4-FFF2-40B4-BE49-F238E27FC236}">
+                  <a16:creationId xmlns:a16="http://schemas.microsoft.com/office/drawing/2014/main" id="{0E4180A8-63F5-3E9C-DAB6-12D5903CD444}"/>
+                </a:ext>
+              </a:extLst>
+            </p:cNvPr>
+            <p:cNvSpPr/>
+            <p:nvPr/>
+          </p:nvSpPr>
+          <p:spPr>
+            <a:xfrm>
+              <a:off x="9871170" y="3859672"/>
+              <a:ext cx="121186" cy="127613"/>
+            </a:xfrm>
+            <a:prstGeom prst="ellipse">
+              <a:avLst/>
+            </a:prstGeom>
+            <a:noFill/>
+            <a:ln>
+              <a:noFill/>
+            </a:ln>
+          </p:spPr>
+          <p:style>
+            <a:lnRef idx="2">
+              <a:schemeClr val="accent1">
+                <a:shade val="15000"/>
+              </a:schemeClr>
+            </a:lnRef>
+            <a:fillRef idx="1">
+              <a:schemeClr val="accent1"/>
+            </a:fillRef>
+            <a:effectRef idx="0">
+              <a:schemeClr val="accent1"/>
+            </a:effectRef>
+            <a:fontRef idx="minor">
+              <a:schemeClr val="lt1"/>
+            </a:fontRef>
+          </p:style>
+          <p:txBody>
+            <a:bodyPr rtlCol="0" anchor="ctr"/>
+            <a:lstStyle/>
+            <a:p>
+              <a:pPr algn="ctr"/>
+              <a:endParaRPr lang="en-US"/>
+            </a:p>
+          </p:txBody>
+        </p:sp>
+        <p:cxnSp>
+          <p:nvCxnSpPr>
+            <p:cNvPr id="72" name="Curved Connector 71">
+              <a:extLst>
+                <a:ext uri="{FF2B5EF4-FFF2-40B4-BE49-F238E27FC236}">
+                  <a16:creationId xmlns:a16="http://schemas.microsoft.com/office/drawing/2014/main" id="{D4B3528C-8E59-7859-D76B-3480A1D44211}"/>
+                </a:ext>
+              </a:extLst>
+            </p:cNvPr>
+            <p:cNvCxnSpPr>
+              <a:cxnSpLocks/>
+              <a:stCxn id="27" idx="3"/>
+              <a:endCxn id="69" idx="2"/>
+            </p:cNvCxnSpPr>
+            <p:nvPr/>
+          </p:nvCxnSpPr>
+          <p:spPr>
+            <a:xfrm>
+              <a:off x="8375298" y="1853978"/>
+              <a:ext cx="1495872" cy="1404481"/>
+            </a:xfrm>
+            <a:prstGeom prst="curvedConnector3">
+              <a:avLst/>
+            </a:prstGeom>
+            <a:ln w="28575">
+              <a:solidFill>
+                <a:schemeClr val="tx1"/>
+              </a:solidFill>
+              <a:tailEnd type="triangle" w="lg" len="lg"/>
+            </a:ln>
+          </p:spPr>
+          <p:style>
+            <a:lnRef idx="2">
+              <a:schemeClr val="accent1"/>
+            </a:lnRef>
+            <a:fillRef idx="0">
+              <a:schemeClr val="accent1"/>
+            </a:fillRef>
+            <a:effectRef idx="1">
+              <a:schemeClr val="accent1"/>
+            </a:effectRef>
+            <a:fontRef idx="minor">
+              <a:schemeClr val="tx1"/>
+            </a:fontRef>
+          </p:style>
+        </p:cxnSp>
+        <p:cxnSp>
+          <p:nvCxnSpPr>
+            <p:cNvPr id="75" name="Curved Connector 74">
+              <a:extLst>
+                <a:ext uri="{FF2B5EF4-FFF2-40B4-BE49-F238E27FC236}">
+                  <a16:creationId xmlns:a16="http://schemas.microsoft.com/office/drawing/2014/main" id="{363EF6CB-581D-5B7E-E167-4103D8FE2439}"/>
+                </a:ext>
+              </a:extLst>
+            </p:cNvPr>
+            <p:cNvCxnSpPr>
+              <a:cxnSpLocks/>
+              <a:stCxn id="2" idx="3"/>
+              <a:endCxn id="68" idx="2"/>
+            </p:cNvCxnSpPr>
+            <p:nvPr/>
+          </p:nvCxnSpPr>
+          <p:spPr>
+            <a:xfrm>
+              <a:off x="8375298" y="2722474"/>
+              <a:ext cx="1495872" cy="702240"/>
+            </a:xfrm>
+            <a:prstGeom prst="curvedConnector3">
+              <a:avLst/>
+            </a:prstGeom>
+            <a:ln w="28575">
+              <a:solidFill>
+                <a:schemeClr val="tx1"/>
+              </a:solidFill>
+              <a:tailEnd type="triangle" w="lg" len="lg"/>
+            </a:ln>
+          </p:spPr>
+          <p:style>
+            <a:lnRef idx="2">
+              <a:schemeClr val="accent1"/>
+            </a:lnRef>
+            <a:fillRef idx="0">
+              <a:schemeClr val="accent1"/>
+            </a:fillRef>
+            <a:effectRef idx="1">
+              <a:schemeClr val="accent1"/>
+            </a:effectRef>
+            <a:fontRef idx="minor">
+              <a:schemeClr val="tx1"/>
+            </a:fontRef>
+          </p:style>
+        </p:cxnSp>
+        <p:cxnSp>
+          <p:nvCxnSpPr>
+            <p:cNvPr id="78" name="Curved Connector 77">
+              <a:extLst>
+                <a:ext uri="{FF2B5EF4-FFF2-40B4-BE49-F238E27FC236}">
+                  <a16:creationId xmlns:a16="http://schemas.microsoft.com/office/drawing/2014/main" id="{42FCE940-D2B5-C679-E352-FCB4821AFDDD}"/>
+                </a:ext>
+              </a:extLst>
+            </p:cNvPr>
+            <p:cNvCxnSpPr>
+              <a:cxnSpLocks/>
+              <a:stCxn id="3" idx="3"/>
+              <a:endCxn id="67" idx="2"/>
+            </p:cNvCxnSpPr>
+            <p:nvPr/>
+          </p:nvCxnSpPr>
+          <p:spPr>
+            <a:xfrm flipV="1">
+              <a:off x="8375298" y="3590969"/>
+              <a:ext cx="1495872" cy="1"/>
+            </a:xfrm>
+            <a:prstGeom prst="curvedConnector3">
+              <a:avLst/>
+            </a:prstGeom>
+            <a:ln w="28575">
+              <a:solidFill>
+                <a:schemeClr val="tx1"/>
+              </a:solidFill>
+              <a:tailEnd type="triangle" w="lg" len="lg"/>
+            </a:ln>
+          </p:spPr>
+          <p:style>
+            <a:lnRef idx="2">
+              <a:schemeClr val="accent1"/>
+            </a:lnRef>
+            <a:fillRef idx="0">
+              <a:schemeClr val="accent1"/>
+            </a:fillRef>
+            <a:effectRef idx="1">
+              <a:schemeClr val="accent1"/>
+            </a:effectRef>
+            <a:fontRef idx="minor">
+              <a:schemeClr val="tx1"/>
+            </a:fontRef>
+          </p:style>
+        </p:cxnSp>
+        <p:cxnSp>
+          <p:nvCxnSpPr>
+            <p:cNvPr id="81" name="Curved Connector 80">
+              <a:extLst>
+                <a:ext uri="{FF2B5EF4-FFF2-40B4-BE49-F238E27FC236}">
+                  <a16:creationId xmlns:a16="http://schemas.microsoft.com/office/drawing/2014/main" id="{7D651BFD-6194-2FC6-C175-68301A74B032}"/>
+                </a:ext>
+              </a:extLst>
+            </p:cNvPr>
+            <p:cNvCxnSpPr>
+              <a:cxnSpLocks/>
+              <a:endCxn id="70" idx="2"/>
+            </p:cNvCxnSpPr>
+            <p:nvPr/>
+          </p:nvCxnSpPr>
+          <p:spPr>
+            <a:xfrm flipV="1">
+              <a:off x="8375297" y="3757224"/>
+              <a:ext cx="1495873" cy="796456"/>
+            </a:xfrm>
+            <a:prstGeom prst="curvedConnector3">
+              <a:avLst/>
+            </a:prstGeom>
+            <a:ln w="28575">
+              <a:solidFill>
+                <a:schemeClr val="tx1"/>
+              </a:solidFill>
+              <a:tailEnd type="triangle" w="lg" len="lg"/>
+            </a:ln>
+          </p:spPr>
+          <p:style>
+            <a:lnRef idx="2">
+              <a:schemeClr val="accent1"/>
+            </a:lnRef>
+            <a:fillRef idx="0">
+              <a:schemeClr val="accent1"/>
+            </a:fillRef>
+            <a:effectRef idx="1">
+              <a:schemeClr val="accent1"/>
+            </a:effectRef>
+            <a:fontRef idx="minor">
+              <a:schemeClr val="tx1"/>
+            </a:fontRef>
+          </p:style>
+        </p:cxnSp>
+        <p:cxnSp>
+          <p:nvCxnSpPr>
+            <p:cNvPr id="84" name="Curved Connector 83">
+              <a:extLst>
+                <a:ext uri="{FF2B5EF4-FFF2-40B4-BE49-F238E27FC236}">
+                  <a16:creationId xmlns:a16="http://schemas.microsoft.com/office/drawing/2014/main" id="{9EC46E83-2D9A-FCB8-BEC7-188C2F21551E}"/>
+                </a:ext>
+              </a:extLst>
+            </p:cNvPr>
+            <p:cNvCxnSpPr>
+              <a:cxnSpLocks/>
+              <a:stCxn id="4" idx="3"/>
+              <a:endCxn id="71" idx="2"/>
+            </p:cNvCxnSpPr>
+            <p:nvPr/>
+          </p:nvCxnSpPr>
+          <p:spPr>
+            <a:xfrm flipV="1">
+              <a:off x="8375296" y="3923479"/>
+              <a:ext cx="1495874" cy="1592911"/>
+            </a:xfrm>
+            <a:prstGeom prst="curvedConnector3">
+              <a:avLst>
+                <a:gd name="adj1" fmla="val 50000"/>
+              </a:avLst>
+            </a:prstGeom>
+            <a:ln w="28575">
+              <a:solidFill>
+                <a:schemeClr val="tx1"/>
+              </a:solidFill>
+              <a:tailEnd type="triangle" w="lg" len="lg"/>
+            </a:ln>
+          </p:spPr>
+          <p:style>
+            <a:lnRef idx="2">
+              <a:schemeClr val="accent1"/>
+            </a:lnRef>
+            <a:fillRef idx="0">
+              <a:schemeClr val="accent1"/>
+            </a:fillRef>
+            <a:effectRef idx="1">
+              <a:schemeClr val="accent1"/>
+            </a:effectRef>
+            <a:fontRef idx="minor">
+              <a:schemeClr val="tx1"/>
+            </a:fontRef>
+          </p:style>
+        </p:cxnSp>
+        <p:sp>
+          <p:nvSpPr>
+            <p:cNvPr id="87" name="TextBox 86">
+              <a:extLst>
+                <a:ext uri="{FF2B5EF4-FFF2-40B4-BE49-F238E27FC236}">
+                  <a16:creationId xmlns:a16="http://schemas.microsoft.com/office/drawing/2014/main" id="{F85E74C5-7CFF-0227-8220-41122AADBAEA}"/>
+                </a:ext>
+              </a:extLst>
+            </p:cNvPr>
+            <p:cNvSpPr txBox="1"/>
+            <p:nvPr/>
+          </p:nvSpPr>
+          <p:spPr>
+            <a:xfrm rot="5400000">
+              <a:off x="5809614" y="4177664"/>
+              <a:ext cx="646331" cy="769441"/>
+            </a:xfrm>
+            <a:prstGeom prst="rect">
+              <a:avLst/>
+            </a:prstGeom>
+            <a:noFill/>
+          </p:spPr>
+          <p:txBody>
+            <a:bodyPr wrap="none" rtlCol="0">
+              <a:spAutoFit/>
+            </a:bodyPr>
+            <a:lstStyle/>
+            <a:p>
+              <a:r>
+                <a:rPr lang="en-US" sz="4400" dirty="0"/>
+                <a:t>…</a:t>
+              </a:r>
+            </a:p>
+          </p:txBody>
+        </p:sp>
+        <p:sp>
+          <p:nvSpPr>
+            <p:cNvPr id="98" name="Rounded Rectangle 97">
+              <a:extLst>
+                <a:ext uri="{FF2B5EF4-FFF2-40B4-BE49-F238E27FC236}">
+                  <a16:creationId xmlns:a16="http://schemas.microsoft.com/office/drawing/2014/main" id="{59BE7DD1-8233-E3AB-9F8B-75737BE7B743}"/>
+                </a:ext>
+              </a:extLst>
+            </p:cNvPr>
+            <p:cNvSpPr/>
+            <p:nvPr/>
+          </p:nvSpPr>
+          <p:spPr>
+            <a:xfrm>
+              <a:off x="3831450" y="542351"/>
+              <a:ext cx="4529099" cy="630201"/>
+            </a:xfrm>
+            <a:prstGeom prst="roundRect">
+              <a:avLst>
+                <a:gd name="adj" fmla="val 50000"/>
+              </a:avLst>
+            </a:prstGeom>
+            <a:noFill/>
+            <a:ln w="31750">
+              <a:noFill/>
+            </a:ln>
+          </p:spPr>
+          <p:style>
+            <a:lnRef idx="2">
+              <a:schemeClr val="accent1">
+                <a:shade val="15000"/>
+              </a:schemeClr>
+            </a:lnRef>
+            <a:fillRef idx="1">
+              <a:schemeClr val="accent1"/>
+            </a:fillRef>
+            <a:effectRef idx="0">
+              <a:schemeClr val="accent1"/>
+            </a:effectRef>
+            <a:fontRef idx="minor">
+              <a:schemeClr val="lt1"/>
+            </a:fontRef>
+          </p:style>
+          <p:txBody>
+            <a:bodyPr rtlCol="0" anchor="ctr"/>
+            <a:lstStyle/>
+            <a:p>
+              <a:pPr algn="ctr"/>
+              <a:r>
+                <a:rPr lang="en-US" sz="3600" u="sng" dirty="0">
+                  <a:solidFill>
+                    <a:schemeClr val="tx1"/>
+                  </a:solidFill>
+                </a:rPr>
+                <a:t>Stage m</a:t>
+              </a:r>
+            </a:p>
+          </p:txBody>
+        </p:sp>
+        <p:sp>
+          <p:nvSpPr>
+            <p:cNvPr id="100" name="Rounded Rectangle 99">
+              <a:extLst>
+                <a:ext uri="{FF2B5EF4-FFF2-40B4-BE49-F238E27FC236}">
+                  <a16:creationId xmlns:a16="http://schemas.microsoft.com/office/drawing/2014/main" id="{455B73F4-CE3B-81EF-A52C-1014347832C6}"/>
+                </a:ext>
+              </a:extLst>
+            </p:cNvPr>
+            <p:cNvSpPr/>
+            <p:nvPr/>
+          </p:nvSpPr>
+          <p:spPr>
+            <a:xfrm>
+              <a:off x="-2107451" y="2509377"/>
+              <a:ext cx="1733320" cy="2163182"/>
+            </a:xfrm>
+            <a:prstGeom prst="roundRect">
+              <a:avLst>
+                <a:gd name="adj" fmla="val 50000"/>
+              </a:avLst>
+            </a:prstGeom>
+            <a:solidFill>
+              <a:schemeClr val="tx1">
+                <a:alpha val="5000"/>
+              </a:schemeClr>
+            </a:solidFill>
+            <a:ln w="31750">
+              <a:solidFill>
+                <a:schemeClr val="tx1"/>
+              </a:solidFill>
+            </a:ln>
+          </p:spPr>
+          <p:style>
+            <a:lnRef idx="2">
+              <a:schemeClr val="accent1">
+                <a:shade val="15000"/>
+              </a:schemeClr>
+            </a:lnRef>
+            <a:fillRef idx="1">
+              <a:schemeClr val="accent1"/>
+            </a:fillRef>
+            <a:effectRef idx="0">
+              <a:schemeClr val="accent1"/>
+            </a:effectRef>
+            <a:fontRef idx="minor">
+              <a:schemeClr val="lt1"/>
+            </a:fontRef>
+          </p:style>
+          <p:txBody>
+            <a:bodyPr rtlCol="0" anchor="ctr"/>
+            <a:lstStyle/>
+            <a:p>
+              <a:pPr algn="ctr"/>
+              <a:r>
+                <a:rPr lang="en-US" dirty="0">
+                  <a:solidFill>
+                    <a:schemeClr val="tx1"/>
+                  </a:solidFill>
+                </a:rPr>
+                <a:t>Start</a:t>
+              </a:r>
+            </a:p>
+          </p:txBody>
+        </p:sp>
+        <p:cxnSp>
+          <p:nvCxnSpPr>
+            <p:cNvPr id="101" name="Curved Connector 100">
+              <a:extLst>
+                <a:ext uri="{FF2B5EF4-FFF2-40B4-BE49-F238E27FC236}">
+                  <a16:creationId xmlns:a16="http://schemas.microsoft.com/office/drawing/2014/main" id="{41E494BB-86FF-48DF-0A84-5B892DD7249E}"/>
+                </a:ext>
+              </a:extLst>
+            </p:cNvPr>
+            <p:cNvCxnSpPr>
+              <a:cxnSpLocks/>
+              <a:stCxn id="100" idx="3"/>
+              <a:endCxn id="5" idx="1"/>
+            </p:cNvCxnSpPr>
+            <p:nvPr/>
+          </p:nvCxnSpPr>
+          <p:spPr>
+            <a:xfrm>
+              <a:off x="-374131" y="3590968"/>
+              <a:ext cx="991136" cy="1"/>
+            </a:xfrm>
+            <a:prstGeom prst="curvedConnector3">
+              <a:avLst>
+                <a:gd name="adj1" fmla="val 50000"/>
+              </a:avLst>
+            </a:prstGeom>
+            <a:ln w="28575">
+              <a:solidFill>
+                <a:schemeClr val="tx1"/>
+              </a:solidFill>
+              <a:tailEnd type="triangle" w="lg" len="lg"/>
+            </a:ln>
+          </p:spPr>
+          <p:style>
+            <a:lnRef idx="2">
+              <a:schemeClr val="accent1"/>
+            </a:lnRef>
+            <a:fillRef idx="0">
+              <a:schemeClr val="accent1"/>
+            </a:fillRef>
+            <a:effectRef idx="1">
+              <a:schemeClr val="accent1"/>
+            </a:effectRef>
+            <a:fontRef idx="minor">
+              <a:schemeClr val="tx1"/>
+            </a:fontRef>
+          </p:style>
+        </p:cxnSp>
+        <p:sp>
+          <p:nvSpPr>
+            <p:cNvPr id="105" name="Rounded Rectangle 104">
+              <a:extLst>
+                <a:ext uri="{FF2B5EF4-FFF2-40B4-BE49-F238E27FC236}">
+                  <a16:creationId xmlns:a16="http://schemas.microsoft.com/office/drawing/2014/main" id="{980C1B93-5194-6DC4-4A02-100766C62FFC}"/>
+                </a:ext>
+              </a:extLst>
+            </p:cNvPr>
+            <p:cNvSpPr/>
+            <p:nvPr/>
+          </p:nvSpPr>
+          <p:spPr>
+            <a:xfrm>
+              <a:off x="14839878" y="2509377"/>
+              <a:ext cx="1733320" cy="2163182"/>
+            </a:xfrm>
+            <a:prstGeom prst="roundRect">
+              <a:avLst>
+                <a:gd name="adj" fmla="val 50000"/>
+              </a:avLst>
+            </a:prstGeom>
+            <a:solidFill>
+              <a:schemeClr val="tx1">
+                <a:alpha val="5000"/>
+              </a:schemeClr>
+            </a:solidFill>
+            <a:ln w="31750">
+              <a:solidFill>
+                <a:schemeClr val="tx1"/>
+              </a:solidFill>
+            </a:ln>
+          </p:spPr>
+          <p:style>
+            <a:lnRef idx="2">
+              <a:schemeClr val="accent1">
+                <a:shade val="15000"/>
+              </a:schemeClr>
+            </a:lnRef>
+            <a:fillRef idx="1">
+              <a:schemeClr val="accent1"/>
+            </a:fillRef>
+            <a:effectRef idx="0">
+              <a:schemeClr val="accent1"/>
+            </a:effectRef>
+            <a:fontRef idx="minor">
+              <a:schemeClr val="lt1"/>
+            </a:fontRef>
+          </p:style>
+          <p:txBody>
+            <a:bodyPr rtlCol="0" anchor="ctr"/>
+            <a:lstStyle/>
+            <a:p>
+              <a:pPr algn="ctr"/>
+              <a:r>
+                <a:rPr lang="en-US" dirty="0">
+                  <a:solidFill>
+                    <a:schemeClr val="tx1"/>
+                  </a:solidFill>
+                </a:rPr>
+                <a:t>End</a:t>
+              </a:r>
+            </a:p>
+          </p:txBody>
+        </p:sp>
+        <p:cxnSp>
+          <p:nvCxnSpPr>
+            <p:cNvPr id="106" name="Curved Connector 105">
+              <a:extLst>
+                <a:ext uri="{FF2B5EF4-FFF2-40B4-BE49-F238E27FC236}">
+                  <a16:creationId xmlns:a16="http://schemas.microsoft.com/office/drawing/2014/main" id="{87B6BE67-06E6-F364-D66F-E6E51F5073ED}"/>
+                </a:ext>
+              </a:extLst>
+            </p:cNvPr>
+            <p:cNvCxnSpPr>
+              <a:cxnSpLocks/>
+              <a:stCxn id="6" idx="3"/>
+              <a:endCxn id="117" idx="1"/>
+            </p:cNvCxnSpPr>
+            <p:nvPr/>
+          </p:nvCxnSpPr>
+          <p:spPr>
+            <a:xfrm flipV="1">
+              <a:off x="11604492" y="3584768"/>
+              <a:ext cx="751033" cy="6201"/>
+            </a:xfrm>
+            <a:prstGeom prst="curvedConnector3">
+              <a:avLst>
+                <a:gd name="adj1" fmla="val 50000"/>
+              </a:avLst>
+            </a:prstGeom>
+            <a:ln w="28575">
+              <a:solidFill>
+                <a:schemeClr val="tx1"/>
+              </a:solidFill>
+              <a:tailEnd type="triangle" w="lg" len="lg"/>
+            </a:ln>
+          </p:spPr>
+          <p:style>
+            <a:lnRef idx="2">
+              <a:schemeClr val="accent1"/>
+            </a:lnRef>
+            <a:fillRef idx="0">
+              <a:schemeClr val="accent1"/>
+            </a:fillRef>
+            <a:effectRef idx="1">
+              <a:schemeClr val="accent1"/>
+            </a:effectRef>
+            <a:fontRef idx="minor">
+              <a:schemeClr val="tx1"/>
+            </a:fontRef>
+          </p:style>
+        </p:cxnSp>
+        <p:cxnSp>
+          <p:nvCxnSpPr>
+            <p:cNvPr id="110" name="Curved Connector 109">
+              <a:extLst>
+                <a:ext uri="{FF2B5EF4-FFF2-40B4-BE49-F238E27FC236}">
+                  <a16:creationId xmlns:a16="http://schemas.microsoft.com/office/drawing/2014/main" id="{3C9B37AE-7320-412F-6470-C1AFB6E25CA3}"/>
+                </a:ext>
+              </a:extLst>
+            </p:cNvPr>
+            <p:cNvCxnSpPr>
+              <a:cxnSpLocks/>
+              <a:stCxn id="117" idx="3"/>
+              <a:endCxn id="105" idx="1"/>
+            </p:cNvCxnSpPr>
+            <p:nvPr/>
+          </p:nvCxnSpPr>
+          <p:spPr>
+            <a:xfrm>
+              <a:off x="14088845" y="3584768"/>
+              <a:ext cx="751033" cy="6200"/>
+            </a:xfrm>
+            <a:prstGeom prst="curvedConnector3">
+              <a:avLst>
+                <a:gd name="adj1" fmla="val 50000"/>
+              </a:avLst>
+            </a:prstGeom>
+            <a:ln w="28575">
+              <a:solidFill>
+                <a:schemeClr val="tx1"/>
+              </a:solidFill>
+              <a:tailEnd type="triangle" w="lg" len="lg"/>
+            </a:ln>
+          </p:spPr>
+          <p:style>
+            <a:lnRef idx="2">
+              <a:schemeClr val="accent1"/>
+            </a:lnRef>
+            <a:fillRef idx="0">
+              <a:schemeClr val="accent1"/>
+            </a:fillRef>
+            <a:effectRef idx="1">
+              <a:schemeClr val="accent1"/>
+            </a:effectRef>
+            <a:fontRef idx="minor">
+              <a:schemeClr val="tx1"/>
+            </a:fontRef>
+          </p:style>
+        </p:cxnSp>
+        <p:cxnSp>
+          <p:nvCxnSpPr>
+            <p:cNvPr id="113" name="Curved Connector 112">
+              <a:extLst>
+                <a:ext uri="{FF2B5EF4-FFF2-40B4-BE49-F238E27FC236}">
+                  <a16:creationId xmlns:a16="http://schemas.microsoft.com/office/drawing/2014/main" id="{39FDEE20-BCF2-C1BA-4483-51020F95094A}"/>
+                </a:ext>
+              </a:extLst>
+            </p:cNvPr>
+            <p:cNvCxnSpPr>
+              <a:cxnSpLocks/>
+              <a:stCxn id="117" idx="2"/>
+              <a:endCxn id="124" idx="3"/>
+            </p:cNvCxnSpPr>
+            <p:nvPr/>
+          </p:nvCxnSpPr>
+          <p:spPr>
+            <a:xfrm rot="5400000">
+              <a:off x="6614570" y="112901"/>
+              <a:ext cx="2642506" cy="10572725"/>
+            </a:xfrm>
+            <a:prstGeom prst="curvedConnector2">
+              <a:avLst/>
+            </a:prstGeom>
+            <a:ln w="28575">
+              <a:solidFill>
+                <a:schemeClr val="tx1"/>
+              </a:solidFill>
+              <a:tailEnd type="triangle" w="lg" len="lg"/>
+            </a:ln>
+          </p:spPr>
+          <p:style>
+            <a:lnRef idx="2">
+              <a:schemeClr val="accent1"/>
+            </a:lnRef>
+            <a:fillRef idx="0">
+              <a:schemeClr val="accent1"/>
+            </a:fillRef>
+            <a:effectRef idx="1">
+              <a:schemeClr val="accent1"/>
+            </a:effectRef>
+            <a:fontRef idx="minor">
+              <a:schemeClr val="tx1"/>
+            </a:fontRef>
+          </p:style>
+        </p:cxnSp>
+        <p:sp>
+          <p:nvSpPr>
+            <p:cNvPr id="117" name="Decision 116">
+              <a:extLst>
+                <a:ext uri="{FF2B5EF4-FFF2-40B4-BE49-F238E27FC236}">
+                  <a16:creationId xmlns:a16="http://schemas.microsoft.com/office/drawing/2014/main" id="{0C121FD1-B3C5-7FAA-A38F-52CD865F3F52}"/>
+                </a:ext>
+              </a:extLst>
+            </p:cNvPr>
+            <p:cNvSpPr/>
+            <p:nvPr/>
+          </p:nvSpPr>
+          <p:spPr>
+            <a:xfrm>
+              <a:off x="12355525" y="3091525"/>
+              <a:ext cx="1733320" cy="986485"/>
+            </a:xfrm>
+            <a:prstGeom prst="flowChartDecision">
+              <a:avLst/>
+            </a:prstGeom>
+            <a:solidFill>
+              <a:schemeClr val="tx1">
+                <a:alpha val="5000"/>
+              </a:schemeClr>
+            </a:solidFill>
+            <a:ln w="31750"/>
+          </p:spPr>
+          <p:style>
+            <a:lnRef idx="2">
+              <a:schemeClr val="accent1">
+                <a:shade val="15000"/>
+              </a:schemeClr>
+            </a:lnRef>
+            <a:fillRef idx="1">
+              <a:schemeClr val="accent1"/>
+            </a:fillRef>
+            <a:effectRef idx="0">
+              <a:schemeClr val="accent1"/>
+            </a:effectRef>
+            <a:fontRef idx="minor">
+              <a:schemeClr val="lt1"/>
+            </a:fontRef>
+          </p:style>
+          <p:txBody>
+            <a:bodyPr rtlCol="0" anchor="ctr"/>
+            <a:lstStyle/>
+            <a:p>
+              <a:pPr algn="ctr"/>
+              <a:r>
+                <a:rPr lang="en-US" dirty="0">
+                  <a:solidFill>
+                    <a:schemeClr val="tx1"/>
+                  </a:solidFill>
+                </a:rPr>
+                <a:t>m= M?</a:t>
+              </a:r>
+            </a:p>
+          </p:txBody>
+        </p:sp>
+        <p:sp>
+          <p:nvSpPr>
+            <p:cNvPr id="124" name="Rectangle 123">
+              <a:extLst>
+                <a:ext uri="{FF2B5EF4-FFF2-40B4-BE49-F238E27FC236}">
+                  <a16:creationId xmlns:a16="http://schemas.microsoft.com/office/drawing/2014/main" id="{63099621-CB18-67E9-CF92-BE49CF94A000}"/>
+                </a:ext>
+              </a:extLst>
+            </p:cNvPr>
+            <p:cNvSpPr/>
+            <p:nvPr/>
+          </p:nvSpPr>
+          <p:spPr>
+            <a:xfrm>
+              <a:off x="317871" y="6403425"/>
+              <a:ext cx="2331589" cy="634181"/>
+            </a:xfrm>
+            <a:prstGeom prst="rect">
+              <a:avLst/>
+            </a:prstGeom>
+            <a:solidFill>
+              <a:schemeClr val="tx1">
+                <a:alpha val="5000"/>
+              </a:schemeClr>
+            </a:solidFill>
+            <a:ln w="31750">
+              <a:solidFill>
+                <a:schemeClr val="tx1"/>
+              </a:solidFill>
+            </a:ln>
+          </p:spPr>
+          <p:style>
+            <a:lnRef idx="2">
+              <a:schemeClr val="accent1">
+                <a:shade val="15000"/>
+              </a:schemeClr>
+            </a:lnRef>
+            <a:fillRef idx="1">
+              <a:schemeClr val="accent1"/>
+            </a:fillRef>
+            <a:effectRef idx="0">
+              <a:schemeClr val="accent1"/>
+            </a:effectRef>
+            <a:fontRef idx="minor">
+              <a:schemeClr val="lt1"/>
+            </a:fontRef>
+          </p:style>
+          <p:txBody>
+            <a:bodyPr rtlCol="0" anchor="ctr"/>
+            <a:lstStyle/>
+            <a:p>
+              <a:pPr algn="ctr"/>
+              <a:r>
+                <a:rPr lang="en-US" dirty="0">
+                  <a:solidFill>
+                    <a:schemeClr val="tx1"/>
+                  </a:solidFill>
+                </a:rPr>
+                <a:t>Increase m</a:t>
+              </a:r>
+            </a:p>
+            <a:p>
+              <a:pPr algn="ctr"/>
+              <a:r>
+                <a:rPr lang="en-US" dirty="0">
+                  <a:solidFill>
+                    <a:schemeClr val="tx1"/>
+                  </a:solidFill>
+                </a:rPr>
+                <a:t>Increase </a:t>
+              </a:r>
+              <a:r>
+                <a:rPr lang="en-US" dirty="0" err="1">
+                  <a:solidFill>
+                    <a:schemeClr val="tx1"/>
+                  </a:solidFill>
+                </a:rPr>
+                <a:t>ε</a:t>
+              </a:r>
+              <a:endParaRPr lang="en-US" dirty="0">
+                <a:solidFill>
+                  <a:schemeClr val="tx1"/>
+                </a:solidFill>
+              </a:endParaRPr>
+            </a:p>
+          </p:txBody>
+        </p:sp>
+        <p:cxnSp>
+          <p:nvCxnSpPr>
+            <p:cNvPr id="127" name="Curved Connector 126">
+              <a:extLst>
+                <a:ext uri="{FF2B5EF4-FFF2-40B4-BE49-F238E27FC236}">
+                  <a16:creationId xmlns:a16="http://schemas.microsoft.com/office/drawing/2014/main" id="{8A5996EC-7003-4DE0-FBD5-C2EB26BBC320}"/>
+                </a:ext>
+              </a:extLst>
+            </p:cNvPr>
+            <p:cNvCxnSpPr>
+              <a:cxnSpLocks/>
+              <a:stCxn id="124" idx="0"/>
+              <a:endCxn id="5" idx="2"/>
+            </p:cNvCxnSpPr>
+            <p:nvPr/>
+          </p:nvCxnSpPr>
+          <p:spPr>
+            <a:xfrm rot="16200000" flipV="1">
+              <a:off x="618234" y="5537992"/>
+              <a:ext cx="1730865" cy="1"/>
+            </a:xfrm>
+            <a:prstGeom prst="curvedConnector3">
+              <a:avLst>
+                <a:gd name="adj1" fmla="val 50000"/>
+              </a:avLst>
+            </a:prstGeom>
+            <a:ln w="28575">
+              <a:solidFill>
+                <a:schemeClr val="tx1"/>
+              </a:solidFill>
+              <a:tailEnd type="triangle" w="lg" len="lg"/>
+            </a:ln>
+          </p:spPr>
+          <p:style>
+            <a:lnRef idx="2">
+              <a:schemeClr val="accent1"/>
+            </a:lnRef>
+            <a:fillRef idx="0">
+              <a:schemeClr val="accent1"/>
+            </a:fillRef>
+            <a:effectRef idx="1">
+              <a:schemeClr val="accent1"/>
+            </a:effectRef>
+            <a:fontRef idx="minor">
+              <a:schemeClr val="tx1"/>
+            </a:fontRef>
+          </p:style>
+        </p:cxnSp>
+      </p:grpSp>
+    </p:spTree>
+    <p:extLst>
+      <p:ext uri="{BB962C8B-B14F-4D97-AF65-F5344CB8AC3E}">
+        <p14:creationId xmlns:p14="http://schemas.microsoft.com/office/powerpoint/2010/main" val="3738329265"/>
+      </p:ext>
+    </p:extLst>
+  </p:cSld>
+  <p:clrMapOvr>
+    <a:masterClrMapping/>
+  </p:clrMapOvr>
+</p:sld>
+</file>
+
 <file path=ppt/slides/slide2.xml><?xml version="1.0" encoding="utf-8"?>
 <p:sld xmlns:a="http://schemas.openxmlformats.org/drawingml/2006/main" xmlns:r="http://schemas.openxmlformats.org/officeDocument/2006/relationships" xmlns:p="http://schemas.openxmlformats.org/presentationml/2006/main">
   <p:cSld>
@@ -6049,10 +8082,10 @@
           <p:nvPr/>
         </p:nvPicPr>
         <p:blipFill>
-          <a:blip r:embed="rId2">
+          <a:blip>
             <a:extLst>
               <a:ext uri="{96DAC541-7B7A-43D3-8B79-37D633B846F1}">
-                <asvg:svgBlip xmlns:asvg="http://schemas.microsoft.com/office/drawing/2016/SVG/main" r:embed="rId3"/>
+                <asvg:svgBlip xmlns:asvg="http://schemas.microsoft.com/office/drawing/2016/SVG/main" r:embed="rId2"/>
               </a:ext>
             </a:extLst>
           </a:blip>
@@ -6085,10 +8118,10 @@
           <p:nvPr/>
         </p:nvPicPr>
         <p:blipFill>
-          <a:blip r:embed="rId2">
+          <a:blip>
             <a:extLst>
               <a:ext uri="{96DAC541-7B7A-43D3-8B79-37D633B846F1}">
-                <asvg:svgBlip xmlns:asvg="http://schemas.microsoft.com/office/drawing/2016/SVG/main" r:embed="rId3"/>
+                <asvg:svgBlip xmlns:asvg="http://schemas.microsoft.com/office/drawing/2016/SVG/main" r:embed="rId2"/>
               </a:ext>
             </a:extLst>
           </a:blip>
@@ -6121,10 +8154,10 @@
           <p:nvPr/>
         </p:nvPicPr>
         <p:blipFill>
-          <a:blip r:embed="rId2">
+          <a:blip>
             <a:extLst>
               <a:ext uri="{96DAC541-7B7A-43D3-8B79-37D633B846F1}">
-                <asvg:svgBlip xmlns:asvg="http://schemas.microsoft.com/office/drawing/2016/SVG/main" r:embed="rId3"/>
+                <asvg:svgBlip xmlns:asvg="http://schemas.microsoft.com/office/drawing/2016/SVG/main" r:embed="rId2"/>
               </a:ext>
             </a:extLst>
           </a:blip>
@@ -6157,10 +8190,10 @@
           <p:nvPr/>
         </p:nvPicPr>
         <p:blipFill>
-          <a:blip r:embed="rId2">
+          <a:blip>
             <a:extLst>
               <a:ext uri="{96DAC541-7B7A-43D3-8B79-37D633B846F1}">
-                <asvg:svgBlip xmlns:asvg="http://schemas.microsoft.com/office/drawing/2016/SVG/main" r:embed="rId3"/>
+                <asvg:svgBlip xmlns:asvg="http://schemas.microsoft.com/office/drawing/2016/SVG/main" r:embed="rId2"/>
               </a:ext>
             </a:extLst>
           </a:blip>
@@ -6193,10 +8226,10 @@
           <p:nvPr/>
         </p:nvPicPr>
         <p:blipFill>
-          <a:blip r:embed="rId2">
+          <a:blip>
             <a:extLst>
               <a:ext uri="{96DAC541-7B7A-43D3-8B79-37D633B846F1}">
-                <asvg:svgBlip xmlns:asvg="http://schemas.microsoft.com/office/drawing/2016/SVG/main" r:embed="rId3"/>
+                <asvg:svgBlip xmlns:asvg="http://schemas.microsoft.com/office/drawing/2016/SVG/main" r:embed="rId2"/>
               </a:ext>
             </a:extLst>
           </a:blip>
@@ -6229,10 +8262,10 @@
           <p:nvPr/>
         </p:nvPicPr>
         <p:blipFill>
-          <a:blip r:embed="rId2">
+          <a:blip>
             <a:extLst>
               <a:ext uri="{96DAC541-7B7A-43D3-8B79-37D633B846F1}">
-                <asvg:svgBlip xmlns:asvg="http://schemas.microsoft.com/office/drawing/2016/SVG/main" r:embed="rId3"/>
+                <asvg:svgBlip xmlns:asvg="http://schemas.microsoft.com/office/drawing/2016/SVG/main" r:embed="rId2"/>
               </a:ext>
             </a:extLst>
           </a:blip>
@@ -6265,10 +8298,10 @@
           <p:nvPr/>
         </p:nvPicPr>
         <p:blipFill>
-          <a:blip r:embed="rId2">
+          <a:blip>
             <a:extLst>
               <a:ext uri="{96DAC541-7B7A-43D3-8B79-37D633B846F1}">
-                <asvg:svgBlip xmlns:asvg="http://schemas.microsoft.com/office/drawing/2016/SVG/main" r:embed="rId3"/>
+                <asvg:svgBlip xmlns:asvg="http://schemas.microsoft.com/office/drawing/2016/SVG/main" r:embed="rId2"/>
               </a:ext>
             </a:extLst>
           </a:blip>
@@ -6301,10 +8334,10 @@
           <p:nvPr/>
         </p:nvPicPr>
         <p:blipFill>
-          <a:blip r:embed="rId2">
+          <a:blip>
             <a:extLst>
               <a:ext uri="{96DAC541-7B7A-43D3-8B79-37D633B846F1}">
-                <asvg:svgBlip xmlns:asvg="http://schemas.microsoft.com/office/drawing/2016/SVG/main" r:embed="rId3"/>
+                <asvg:svgBlip xmlns:asvg="http://schemas.microsoft.com/office/drawing/2016/SVG/main" r:embed="rId2"/>
               </a:ext>
             </a:extLst>
           </a:blip>
@@ -6337,10 +8370,10 @@
           <p:nvPr/>
         </p:nvPicPr>
         <p:blipFill>
-          <a:blip r:embed="rId2">
+          <a:blip>
             <a:extLst>
               <a:ext uri="{96DAC541-7B7A-43D3-8B79-37D633B846F1}">
-                <asvg:svgBlip xmlns:asvg="http://schemas.microsoft.com/office/drawing/2016/SVG/main" r:embed="rId3"/>
+                <asvg:svgBlip xmlns:asvg="http://schemas.microsoft.com/office/drawing/2016/SVG/main" r:embed="rId2"/>
               </a:ext>
             </a:extLst>
           </a:blip>
@@ -6373,10 +8406,10 @@
           <p:nvPr/>
         </p:nvPicPr>
         <p:blipFill>
-          <a:blip r:embed="rId2">
+          <a:blip>
             <a:extLst>
               <a:ext uri="{96DAC541-7B7A-43D3-8B79-37D633B846F1}">
-                <asvg:svgBlip xmlns:asvg="http://schemas.microsoft.com/office/drawing/2016/SVG/main" r:embed="rId3"/>
+                <asvg:svgBlip xmlns:asvg="http://schemas.microsoft.com/office/drawing/2016/SVG/main" r:embed="rId2"/>
               </a:ext>
             </a:extLst>
           </a:blip>
@@ -6409,10 +8442,10 @@
           <p:nvPr/>
         </p:nvPicPr>
         <p:blipFill>
-          <a:blip r:embed="rId2">
+          <a:blip>
             <a:extLst>
               <a:ext uri="{96DAC541-7B7A-43D3-8B79-37D633B846F1}">
-                <asvg:svgBlip xmlns:asvg="http://schemas.microsoft.com/office/drawing/2016/SVG/main" r:embed="rId3"/>
+                <asvg:svgBlip xmlns:asvg="http://schemas.microsoft.com/office/drawing/2016/SVG/main" r:embed="rId2"/>
               </a:ext>
             </a:extLst>
           </a:blip>
@@ -6445,10 +8478,10 @@
           <p:nvPr/>
         </p:nvPicPr>
         <p:blipFill>
-          <a:blip r:embed="rId2">
+          <a:blip>
             <a:extLst>
               <a:ext uri="{96DAC541-7B7A-43D3-8B79-37D633B846F1}">
-                <asvg:svgBlip xmlns:asvg="http://schemas.microsoft.com/office/drawing/2016/SVG/main" r:embed="rId3"/>
+                <asvg:svgBlip xmlns:asvg="http://schemas.microsoft.com/office/drawing/2016/SVG/main" r:embed="rId2"/>
               </a:ext>
             </a:extLst>
           </a:blip>
@@ -6481,10 +8514,10 @@
           <p:nvPr/>
         </p:nvPicPr>
         <p:blipFill>
-          <a:blip r:embed="rId2">
+          <a:blip>
             <a:extLst>
               <a:ext uri="{96DAC541-7B7A-43D3-8B79-37D633B846F1}">
-                <asvg:svgBlip xmlns:asvg="http://schemas.microsoft.com/office/drawing/2016/SVG/main" r:embed="rId3"/>
+                <asvg:svgBlip xmlns:asvg="http://schemas.microsoft.com/office/drawing/2016/SVG/main" r:embed="rId2"/>
               </a:ext>
             </a:extLst>
           </a:blip>
@@ -6517,10 +8550,10 @@
           <p:nvPr/>
         </p:nvPicPr>
         <p:blipFill>
-          <a:blip r:embed="rId2">
+          <a:blip>
             <a:extLst>
               <a:ext uri="{96DAC541-7B7A-43D3-8B79-37D633B846F1}">
-                <asvg:svgBlip xmlns:asvg="http://schemas.microsoft.com/office/drawing/2016/SVG/main" r:embed="rId3"/>
+                <asvg:svgBlip xmlns:asvg="http://schemas.microsoft.com/office/drawing/2016/SVG/main" r:embed="rId2"/>
               </a:ext>
             </a:extLst>
           </a:blip>
@@ -6553,10 +8586,10 @@
           <p:nvPr/>
         </p:nvPicPr>
         <p:blipFill>
-          <a:blip r:embed="rId2">
+          <a:blip>
             <a:extLst>
               <a:ext uri="{96DAC541-7B7A-43D3-8B79-37D633B846F1}">
-                <asvg:svgBlip xmlns:asvg="http://schemas.microsoft.com/office/drawing/2016/SVG/main" r:embed="rId3"/>
+                <asvg:svgBlip xmlns:asvg="http://schemas.microsoft.com/office/drawing/2016/SVG/main" r:embed="rId2"/>
               </a:ext>
             </a:extLst>
           </a:blip>
@@ -6589,10 +8622,10 @@
           <p:nvPr/>
         </p:nvPicPr>
         <p:blipFill>
-          <a:blip r:embed="rId2">
+          <a:blip>
             <a:extLst>
               <a:ext uri="{96DAC541-7B7A-43D3-8B79-37D633B846F1}">
-                <asvg:svgBlip xmlns:asvg="http://schemas.microsoft.com/office/drawing/2016/SVG/main" r:embed="rId3"/>
+                <asvg:svgBlip xmlns:asvg="http://schemas.microsoft.com/office/drawing/2016/SVG/main" r:embed="rId2"/>
               </a:ext>
             </a:extLst>
           </a:blip>
@@ -6625,10 +8658,10 @@
           <p:nvPr/>
         </p:nvPicPr>
         <p:blipFill>
-          <a:blip r:embed="rId2">
+          <a:blip>
             <a:extLst>
               <a:ext uri="{96DAC541-7B7A-43D3-8B79-37D633B846F1}">
-                <asvg:svgBlip xmlns:asvg="http://schemas.microsoft.com/office/drawing/2016/SVG/main" r:embed="rId3"/>
+                <asvg:svgBlip xmlns:asvg="http://schemas.microsoft.com/office/drawing/2016/SVG/main" r:embed="rId2"/>
               </a:ext>
             </a:extLst>
           </a:blip>
@@ -7048,10 +9081,10 @@
           <p:nvPr/>
         </p:nvPicPr>
         <p:blipFill>
-          <a:blip r:embed="rId2">
+          <a:blip>
             <a:extLst>
               <a:ext uri="{96DAC541-7B7A-43D3-8B79-37D633B846F1}">
-                <asvg:svgBlip xmlns:asvg="http://schemas.microsoft.com/office/drawing/2016/SVG/main" r:embed="rId3"/>
+                <asvg:svgBlip xmlns:asvg="http://schemas.microsoft.com/office/drawing/2016/SVG/main" r:embed="rId2"/>
               </a:ext>
             </a:extLst>
           </a:blip>
@@ -7084,10 +9117,10 @@
           <p:nvPr/>
         </p:nvPicPr>
         <p:blipFill>
-          <a:blip r:embed="rId4">
+          <a:blip>
             <a:extLst>
               <a:ext uri="{96DAC541-7B7A-43D3-8B79-37D633B846F1}">
-                <asvg:svgBlip xmlns:asvg="http://schemas.microsoft.com/office/drawing/2016/SVG/main" r:embed="rId5"/>
+                <asvg:svgBlip xmlns:asvg="http://schemas.microsoft.com/office/drawing/2016/SVG/main" r:embed="rId3"/>
               </a:ext>
             </a:extLst>
           </a:blip>
@@ -7120,10 +9153,10 @@
           <p:nvPr/>
         </p:nvPicPr>
         <p:blipFill>
-          <a:blip r:embed="rId6">
+          <a:blip>
             <a:extLst>
               <a:ext uri="{96DAC541-7B7A-43D3-8B79-37D633B846F1}">
-                <asvg:svgBlip xmlns:asvg="http://schemas.microsoft.com/office/drawing/2016/SVG/main" r:embed="rId7"/>
+                <asvg:svgBlip xmlns:asvg="http://schemas.microsoft.com/office/drawing/2016/SVG/main" r:embed="rId4"/>
               </a:ext>
             </a:extLst>
           </a:blip>
@@ -7156,10 +9189,10 @@
           <p:nvPr/>
         </p:nvPicPr>
         <p:blipFill>
-          <a:blip r:embed="rId8">
+          <a:blip>
             <a:extLst>
               <a:ext uri="{96DAC541-7B7A-43D3-8B79-37D633B846F1}">
-                <asvg:svgBlip xmlns:asvg="http://schemas.microsoft.com/office/drawing/2016/SVG/main" r:embed="rId9"/>
+                <asvg:svgBlip xmlns:asvg="http://schemas.microsoft.com/office/drawing/2016/SVG/main" r:embed="rId5"/>
               </a:ext>
             </a:extLst>
           </a:blip>
@@ -7938,10 +9971,10 @@
           <p:nvPr/>
         </p:nvPicPr>
         <p:blipFill>
-          <a:blip r:embed="rId2">
+          <a:blip>
             <a:extLst>
               <a:ext uri="{96DAC541-7B7A-43D3-8B79-37D633B846F1}">
-                <asvg:svgBlip xmlns:asvg="http://schemas.microsoft.com/office/drawing/2016/SVG/main" r:embed="rId3"/>
+                <asvg:svgBlip xmlns:asvg="http://schemas.microsoft.com/office/drawing/2016/SVG/main" r:embed="rId2"/>
               </a:ext>
             </a:extLst>
           </a:blip>
@@ -7973,10 +10006,10 @@
           <p:nvPr/>
         </p:nvPicPr>
         <p:blipFill>
-          <a:blip r:embed="rId2">
+          <a:blip>
             <a:extLst>
               <a:ext uri="{96DAC541-7B7A-43D3-8B79-37D633B846F1}">
-                <asvg:svgBlip xmlns:asvg="http://schemas.microsoft.com/office/drawing/2016/SVG/main" r:embed="rId3"/>
+                <asvg:svgBlip xmlns:asvg="http://schemas.microsoft.com/office/drawing/2016/SVG/main" r:embed="rId2"/>
               </a:ext>
             </a:extLst>
           </a:blip>
@@ -8008,10 +10041,10 @@
           <p:nvPr/>
         </p:nvPicPr>
         <p:blipFill>
-          <a:blip r:embed="rId2">
+          <a:blip>
             <a:extLst>
               <a:ext uri="{96DAC541-7B7A-43D3-8B79-37D633B846F1}">
-                <asvg:svgBlip xmlns:asvg="http://schemas.microsoft.com/office/drawing/2016/SVG/main" r:embed="rId3"/>
+                <asvg:svgBlip xmlns:asvg="http://schemas.microsoft.com/office/drawing/2016/SVG/main" r:embed="rId2"/>
               </a:ext>
             </a:extLst>
           </a:blip>
@@ -8043,10 +10076,10 @@
           <p:nvPr/>
         </p:nvPicPr>
         <p:blipFill>
-          <a:blip r:embed="rId4">
+          <a:blip>
             <a:extLst>
               <a:ext uri="{96DAC541-7B7A-43D3-8B79-37D633B846F1}">
-                <asvg:svgBlip xmlns:asvg="http://schemas.microsoft.com/office/drawing/2016/SVG/main" r:embed="rId5"/>
+                <asvg:svgBlip xmlns:asvg="http://schemas.microsoft.com/office/drawing/2016/SVG/main" r:embed="rId3"/>
               </a:ext>
             </a:extLst>
           </a:blip>
@@ -8079,10 +10112,10 @@
           <p:nvPr/>
         </p:nvPicPr>
         <p:blipFill>
-          <a:blip r:embed="rId4">
+          <a:blip>
             <a:extLst>
               <a:ext uri="{96DAC541-7B7A-43D3-8B79-37D633B846F1}">
-                <asvg:svgBlip xmlns:asvg="http://schemas.microsoft.com/office/drawing/2016/SVG/main" r:embed="rId5"/>
+                <asvg:svgBlip xmlns:asvg="http://schemas.microsoft.com/office/drawing/2016/SVG/main" r:embed="rId3"/>
               </a:ext>
             </a:extLst>
           </a:blip>
@@ -8115,10 +10148,10 @@
           <p:nvPr/>
         </p:nvPicPr>
         <p:blipFill>
-          <a:blip r:embed="rId6">
+          <a:blip>
             <a:extLst>
               <a:ext uri="{96DAC541-7B7A-43D3-8B79-37D633B846F1}">
-                <asvg:svgBlip xmlns:asvg="http://schemas.microsoft.com/office/drawing/2016/SVG/main" r:embed="rId7"/>
+                <asvg:svgBlip xmlns:asvg="http://schemas.microsoft.com/office/drawing/2016/SVG/main" r:embed="rId4"/>
               </a:ext>
             </a:extLst>
           </a:blip>
@@ -8151,10 +10184,10 @@
           <p:nvPr/>
         </p:nvPicPr>
         <p:blipFill>
-          <a:blip r:embed="rId2">
+          <a:blip>
             <a:extLst>
               <a:ext uri="{96DAC541-7B7A-43D3-8B79-37D633B846F1}">
-                <asvg:svgBlip xmlns:asvg="http://schemas.microsoft.com/office/drawing/2016/SVG/main" r:embed="rId3"/>
+                <asvg:svgBlip xmlns:asvg="http://schemas.microsoft.com/office/drawing/2016/SVG/main" r:embed="rId2"/>
               </a:ext>
             </a:extLst>
           </a:blip>
@@ -8186,10 +10219,10 @@
           <p:nvPr/>
         </p:nvPicPr>
         <p:blipFill>
-          <a:blip r:embed="rId4">
+          <a:blip>
             <a:extLst>
               <a:ext uri="{96DAC541-7B7A-43D3-8B79-37D633B846F1}">
-                <asvg:svgBlip xmlns:asvg="http://schemas.microsoft.com/office/drawing/2016/SVG/main" r:embed="rId5"/>
+                <asvg:svgBlip xmlns:asvg="http://schemas.microsoft.com/office/drawing/2016/SVG/main" r:embed="rId3"/>
               </a:ext>
             </a:extLst>
           </a:blip>
@@ -8222,10 +10255,10 @@
           <p:nvPr/>
         </p:nvPicPr>
         <p:blipFill>
-          <a:blip r:embed="rId4">
+          <a:blip>
             <a:extLst>
               <a:ext uri="{96DAC541-7B7A-43D3-8B79-37D633B846F1}">
-                <asvg:svgBlip xmlns:asvg="http://schemas.microsoft.com/office/drawing/2016/SVG/main" r:embed="rId5"/>
+                <asvg:svgBlip xmlns:asvg="http://schemas.microsoft.com/office/drawing/2016/SVG/main" r:embed="rId3"/>
               </a:ext>
             </a:extLst>
           </a:blip>
@@ -8258,10 +10291,10 @@
           <p:nvPr/>
         </p:nvPicPr>
         <p:blipFill>
-          <a:blip r:embed="rId6">
+          <a:blip>
             <a:extLst>
               <a:ext uri="{96DAC541-7B7A-43D3-8B79-37D633B846F1}">
-                <asvg:svgBlip xmlns:asvg="http://schemas.microsoft.com/office/drawing/2016/SVG/main" r:embed="rId7"/>
+                <asvg:svgBlip xmlns:asvg="http://schemas.microsoft.com/office/drawing/2016/SVG/main" r:embed="rId4"/>
               </a:ext>
             </a:extLst>
           </a:blip>
@@ -8294,10 +10327,10 @@
           <p:nvPr/>
         </p:nvPicPr>
         <p:blipFill>
-          <a:blip r:embed="rId2">
+          <a:blip>
             <a:extLst>
               <a:ext uri="{96DAC541-7B7A-43D3-8B79-37D633B846F1}">
-                <asvg:svgBlip xmlns:asvg="http://schemas.microsoft.com/office/drawing/2016/SVG/main" r:embed="rId3"/>
+                <asvg:svgBlip xmlns:asvg="http://schemas.microsoft.com/office/drawing/2016/SVG/main" r:embed="rId2"/>
               </a:ext>
             </a:extLst>
           </a:blip>
@@ -8329,10 +10362,10 @@
           <p:nvPr/>
         </p:nvPicPr>
         <p:blipFill>
-          <a:blip r:embed="rId2">
+          <a:blip>
             <a:extLst>
               <a:ext uri="{96DAC541-7B7A-43D3-8B79-37D633B846F1}">
-                <asvg:svgBlip xmlns:asvg="http://schemas.microsoft.com/office/drawing/2016/SVG/main" r:embed="rId3"/>
+                <asvg:svgBlip xmlns:asvg="http://schemas.microsoft.com/office/drawing/2016/SVG/main" r:embed="rId2"/>
               </a:ext>
             </a:extLst>
           </a:blip>
@@ -8364,10 +10397,10 @@
           <p:nvPr/>
         </p:nvPicPr>
         <p:blipFill>
-          <a:blip r:embed="rId2">
+          <a:blip>
             <a:extLst>
               <a:ext uri="{96DAC541-7B7A-43D3-8B79-37D633B846F1}">
-                <asvg:svgBlip xmlns:asvg="http://schemas.microsoft.com/office/drawing/2016/SVG/main" r:embed="rId3"/>
+                <asvg:svgBlip xmlns:asvg="http://schemas.microsoft.com/office/drawing/2016/SVG/main" r:embed="rId2"/>
               </a:ext>
             </a:extLst>
           </a:blip>
@@ -8399,10 +10432,10 @@
           <p:nvPr/>
         </p:nvPicPr>
         <p:blipFill>
-          <a:blip r:embed="rId8">
+          <a:blip>
             <a:extLst>
               <a:ext uri="{96DAC541-7B7A-43D3-8B79-37D633B846F1}">
-                <asvg:svgBlip xmlns:asvg="http://schemas.microsoft.com/office/drawing/2016/SVG/main" r:embed="rId9"/>
+                <asvg:svgBlip xmlns:asvg="http://schemas.microsoft.com/office/drawing/2016/SVG/main" r:embed="rId5"/>
               </a:ext>
             </a:extLst>
           </a:blip>
@@ -8434,10 +10467,10 @@
           <p:nvPr/>
         </p:nvPicPr>
         <p:blipFill>
-          <a:blip r:embed="rId8">
+          <a:blip>
             <a:extLst>
               <a:ext uri="{96DAC541-7B7A-43D3-8B79-37D633B846F1}">
-                <asvg:svgBlip xmlns:asvg="http://schemas.microsoft.com/office/drawing/2016/SVG/main" r:embed="rId9"/>
+                <asvg:svgBlip xmlns:asvg="http://schemas.microsoft.com/office/drawing/2016/SVG/main" r:embed="rId5"/>
               </a:ext>
             </a:extLst>
           </a:blip>
@@ -8470,10 +10503,10 @@
           <p:nvPr/>
         </p:nvPicPr>
         <p:blipFill>
-          <a:blip r:embed="rId8">
+          <a:blip>
             <a:extLst>
               <a:ext uri="{96DAC541-7B7A-43D3-8B79-37D633B846F1}">
-                <asvg:svgBlip xmlns:asvg="http://schemas.microsoft.com/office/drawing/2016/SVG/main" r:embed="rId9"/>
+                <asvg:svgBlip xmlns:asvg="http://schemas.microsoft.com/office/drawing/2016/SVG/main" r:embed="rId5"/>
               </a:ext>
             </a:extLst>
           </a:blip>
@@ -8506,10 +10539,10 @@
           <p:nvPr/>
         </p:nvPicPr>
         <p:blipFill>
-          <a:blip r:embed="rId2">
+          <a:blip>
             <a:extLst>
               <a:ext uri="{96DAC541-7B7A-43D3-8B79-37D633B846F1}">
-                <asvg:svgBlip xmlns:asvg="http://schemas.microsoft.com/office/drawing/2016/SVG/main" r:embed="rId3"/>
+                <asvg:svgBlip xmlns:asvg="http://schemas.microsoft.com/office/drawing/2016/SVG/main" r:embed="rId2"/>
               </a:ext>
             </a:extLst>
           </a:blip>
@@ -8913,8 +10946,8 @@
           <a:chExt cx="0" cy="0"/>
         </a:xfrm>
       </p:grpSpPr>
-      <mc:AlternateContent xmlns:mc="http://schemas.openxmlformats.org/markup-compatibility/2006">
-        <mc:Choice xmlns:a14="http://schemas.microsoft.com/office/drawing/2010/main" Requires="a14">
+      <mc:AlternateContent xmlns:mc="http://schemas.openxmlformats.org/markup-compatibility/2006" xmlns:a14="http://schemas.microsoft.com/office/drawing/2010/main">
+        <mc:Choice Requires="a14">
           <p:sp>
             <p:nvSpPr>
               <p:cNvPr id="2" name="TextBox 1">
@@ -9508,7 +11541,7 @@
             </p:txBody>
           </p:sp>
         </mc:Choice>
-        <mc:Fallback>
+        <mc:Fallback xmlns="">
           <p:sp>
             <p:nvSpPr>
               <p:cNvPr id="2" name="TextBox 1">
@@ -9919,10 +11952,10 @@
           <p:nvPr/>
         </p:nvPicPr>
         <p:blipFill>
-          <a:blip r:embed="rId3">
+          <a:blip>
             <a:extLst>
               <a:ext uri="{96DAC541-7B7A-43D3-8B79-37D633B846F1}">
-                <asvg:svgBlip xmlns:asvg="http://schemas.microsoft.com/office/drawing/2016/SVG/main" r:embed="rId4"/>
+                <asvg:svgBlip xmlns:asvg="http://schemas.microsoft.com/office/drawing/2016/SVG/main" r:embed="rId3"/>
               </a:ext>
             </a:extLst>
           </a:blip>
@@ -9955,10 +11988,10 @@
           <p:nvPr/>
         </p:nvPicPr>
         <p:blipFill>
-          <a:blip r:embed="rId5">
+          <a:blip>
             <a:extLst>
               <a:ext uri="{96DAC541-7B7A-43D3-8B79-37D633B846F1}">
-                <asvg:svgBlip xmlns:asvg="http://schemas.microsoft.com/office/drawing/2016/SVG/main" r:embed="rId6"/>
+                <asvg:svgBlip xmlns:asvg="http://schemas.microsoft.com/office/drawing/2016/SVG/main" r:embed="rId4"/>
               </a:ext>
             </a:extLst>
           </a:blip>
@@ -9991,10 +12024,10 @@
           <p:nvPr/>
         </p:nvPicPr>
         <p:blipFill>
-          <a:blip r:embed="rId7">
+          <a:blip>
             <a:extLst>
               <a:ext uri="{96DAC541-7B7A-43D3-8B79-37D633B846F1}">
-                <asvg:svgBlip xmlns:asvg="http://schemas.microsoft.com/office/drawing/2016/SVG/main" r:embed="rId8"/>
+                <asvg:svgBlip xmlns:asvg="http://schemas.microsoft.com/office/drawing/2016/SVG/main" r:embed="rId5"/>
               </a:ext>
             </a:extLst>
           </a:blip>
@@ -10125,8 +12158,8 @@
           <a:chExt cx="0" cy="0"/>
         </a:xfrm>
       </p:grpSpPr>
-      <mc:AlternateContent xmlns:mc="http://schemas.openxmlformats.org/markup-compatibility/2006">
-        <mc:Choice xmlns:a14="http://schemas.microsoft.com/office/drawing/2010/main" Requires="a14">
+      <mc:AlternateContent xmlns:mc="http://schemas.openxmlformats.org/markup-compatibility/2006" xmlns:a14="http://schemas.microsoft.com/office/drawing/2010/main">
+        <mc:Choice Requires="a14">
           <p:sp>
             <p:nvSpPr>
               <p:cNvPr id="2" name="TextBox 1">
@@ -10720,7 +12753,7 @@
             </p:txBody>
           </p:sp>
         </mc:Choice>
-        <mc:Fallback>
+        <mc:Fallback xmlns="">
           <p:sp>
             <p:nvSpPr>
               <p:cNvPr id="2" name="TextBox 1">
@@ -11131,10 +13164,10 @@
           <p:nvPr/>
         </p:nvPicPr>
         <p:blipFill>
-          <a:blip r:embed="rId3">
+          <a:blip>
             <a:extLst>
               <a:ext uri="{96DAC541-7B7A-43D3-8B79-37D633B846F1}">
-                <asvg:svgBlip xmlns:asvg="http://schemas.microsoft.com/office/drawing/2016/SVG/main" r:embed="rId4"/>
+                <asvg:svgBlip xmlns:asvg="http://schemas.microsoft.com/office/drawing/2016/SVG/main" r:embed="rId3"/>
               </a:ext>
             </a:extLst>
           </a:blip>
@@ -11167,10 +13200,10 @@
           <p:nvPr/>
         </p:nvPicPr>
         <p:blipFill>
-          <a:blip r:embed="rId5">
+          <a:blip>
             <a:extLst>
               <a:ext uri="{96DAC541-7B7A-43D3-8B79-37D633B846F1}">
-                <asvg:svgBlip xmlns:asvg="http://schemas.microsoft.com/office/drawing/2016/SVG/main" r:embed="rId6"/>
+                <asvg:svgBlip xmlns:asvg="http://schemas.microsoft.com/office/drawing/2016/SVG/main" r:embed="rId4"/>
               </a:ext>
             </a:extLst>
           </a:blip>
@@ -11203,10 +13236,10 @@
           <p:nvPr/>
         </p:nvPicPr>
         <p:blipFill>
-          <a:blip r:embed="rId7">
+          <a:blip>
             <a:extLst>
               <a:ext uri="{96DAC541-7B7A-43D3-8B79-37D633B846F1}">
-                <asvg:svgBlip xmlns:asvg="http://schemas.microsoft.com/office/drawing/2016/SVG/main" r:embed="rId8"/>
+                <asvg:svgBlip xmlns:asvg="http://schemas.microsoft.com/office/drawing/2016/SVG/main" r:embed="rId5"/>
               </a:ext>
             </a:extLst>
           </a:blip>
@@ -11594,8 +13627,8 @@
           <a:chExt cx="0" cy="0"/>
         </a:xfrm>
       </p:grpSpPr>
-      <mc:AlternateContent xmlns:mc="http://schemas.openxmlformats.org/markup-compatibility/2006">
-        <mc:Choice xmlns:a14="http://schemas.microsoft.com/office/drawing/2010/main" Requires="a14">
+      <mc:AlternateContent xmlns:mc="http://schemas.openxmlformats.org/markup-compatibility/2006" xmlns:a14="http://schemas.microsoft.com/office/drawing/2010/main">
+        <mc:Choice Requires="a14">
           <p:sp>
             <p:nvSpPr>
               <p:cNvPr id="2" name="TextBox 1">
@@ -12208,7 +14241,7 @@
             </p:txBody>
           </p:sp>
         </mc:Choice>
-        <mc:Fallback>
+        <mc:Fallback xmlns="">
           <p:sp>
             <p:nvSpPr>
               <p:cNvPr id="2" name="TextBox 1">
@@ -12619,10 +14652,10 @@
           <p:nvPr/>
         </p:nvPicPr>
         <p:blipFill>
-          <a:blip r:embed="rId3">
+          <a:blip>
             <a:extLst>
               <a:ext uri="{96DAC541-7B7A-43D3-8B79-37D633B846F1}">
-                <asvg:svgBlip xmlns:asvg="http://schemas.microsoft.com/office/drawing/2016/SVG/main" r:embed="rId4"/>
+                <asvg:svgBlip xmlns:asvg="http://schemas.microsoft.com/office/drawing/2016/SVG/main" r:embed="rId3"/>
               </a:ext>
             </a:extLst>
           </a:blip>
@@ -12655,10 +14688,10 @@
           <p:nvPr/>
         </p:nvPicPr>
         <p:blipFill>
-          <a:blip r:embed="rId5">
+          <a:blip>
             <a:extLst>
               <a:ext uri="{96DAC541-7B7A-43D3-8B79-37D633B846F1}">
-                <asvg:svgBlip xmlns:asvg="http://schemas.microsoft.com/office/drawing/2016/SVG/main" r:embed="rId6"/>
+                <asvg:svgBlip xmlns:asvg="http://schemas.microsoft.com/office/drawing/2016/SVG/main" r:embed="rId4"/>
               </a:ext>
             </a:extLst>
           </a:blip>
@@ -12691,10 +14724,10 @@
           <p:nvPr/>
         </p:nvPicPr>
         <p:blipFill>
-          <a:blip r:embed="rId7">
+          <a:blip>
             <a:extLst>
               <a:ext uri="{96DAC541-7B7A-43D3-8B79-37D633B846F1}">
-                <asvg:svgBlip xmlns:asvg="http://schemas.microsoft.com/office/drawing/2016/SVG/main" r:embed="rId8"/>
+                <asvg:svgBlip xmlns:asvg="http://schemas.microsoft.com/office/drawing/2016/SVG/main" r:embed="rId5"/>
               </a:ext>
             </a:extLst>
           </a:blip>
@@ -12789,8 +14822,8 @@
           </a:p>
         </p:txBody>
       </p:sp>
-      <mc:AlternateContent xmlns:mc="http://schemas.openxmlformats.org/markup-compatibility/2006">
-        <mc:Choice xmlns:a14="http://schemas.microsoft.com/office/drawing/2010/main" Requires="a14">
+      <mc:AlternateContent xmlns:mc="http://schemas.openxmlformats.org/markup-compatibility/2006" xmlns:a14="http://schemas.microsoft.com/office/drawing/2010/main">
+        <mc:Choice Requires="a14">
           <p:sp>
             <p:nvSpPr>
               <p:cNvPr id="4" name="TextBox 3">
@@ -13403,7 +15436,7 @@
             </p:txBody>
           </p:sp>
         </mc:Choice>
-        <mc:Fallback>
+        <mc:Fallback xmlns="">
           <p:sp>
             <p:nvSpPr>
               <p:cNvPr id="4" name="TextBox 3">
@@ -13814,10 +15847,10 @@
           <p:nvPr/>
         </p:nvPicPr>
         <p:blipFill>
-          <a:blip r:embed="rId3">
+          <a:blip>
             <a:extLst>
               <a:ext uri="{96DAC541-7B7A-43D3-8B79-37D633B846F1}">
-                <asvg:svgBlip xmlns:asvg="http://schemas.microsoft.com/office/drawing/2016/SVG/main" r:embed="rId4"/>
+                <asvg:svgBlip xmlns:asvg="http://schemas.microsoft.com/office/drawing/2016/SVG/main" r:embed="rId3"/>
               </a:ext>
             </a:extLst>
           </a:blip>
@@ -13850,10 +15883,10 @@
           <p:nvPr/>
         </p:nvPicPr>
         <p:blipFill>
-          <a:blip r:embed="rId5">
+          <a:blip>
             <a:extLst>
               <a:ext uri="{96DAC541-7B7A-43D3-8B79-37D633B846F1}">
-                <asvg:svgBlip xmlns:asvg="http://schemas.microsoft.com/office/drawing/2016/SVG/main" r:embed="rId6"/>
+                <asvg:svgBlip xmlns:asvg="http://schemas.microsoft.com/office/drawing/2016/SVG/main" r:embed="rId4"/>
               </a:ext>
             </a:extLst>
           </a:blip>
@@ -13886,10 +15919,10 @@
           <p:nvPr/>
         </p:nvPicPr>
         <p:blipFill>
-          <a:blip r:embed="rId7">
+          <a:blip>
             <a:extLst>
               <a:ext uri="{96DAC541-7B7A-43D3-8B79-37D633B846F1}">
-                <asvg:svgBlip xmlns:asvg="http://schemas.microsoft.com/office/drawing/2016/SVG/main" r:embed="rId8"/>
+                <asvg:svgBlip xmlns:asvg="http://schemas.microsoft.com/office/drawing/2016/SVG/main" r:embed="rId5"/>
               </a:ext>
             </a:extLst>
           </a:blip>
@@ -14081,8 +16114,8 @@
           <a:chExt cx="0" cy="0"/>
         </a:xfrm>
       </p:grpSpPr>
-      <mc:AlternateContent xmlns:mc="http://schemas.openxmlformats.org/markup-compatibility/2006">
-        <mc:Choice xmlns:a14="http://schemas.microsoft.com/office/drawing/2010/main" Requires="a14">
+      <mc:AlternateContent xmlns:mc="http://schemas.openxmlformats.org/markup-compatibility/2006" xmlns:a14="http://schemas.microsoft.com/office/drawing/2010/main">
+        <mc:Choice Requires="a14">
           <p:sp>
             <p:nvSpPr>
               <p:cNvPr id="2" name="TextBox 1">
@@ -14695,7 +16728,7 @@
             </p:txBody>
           </p:sp>
         </mc:Choice>
-        <mc:Fallback>
+        <mc:Fallback xmlns="">
           <p:sp>
             <p:nvSpPr>
               <p:cNvPr id="2" name="TextBox 1">
@@ -15106,10 +17139,10 @@
           <p:nvPr/>
         </p:nvPicPr>
         <p:blipFill>
-          <a:blip r:embed="rId3">
+          <a:blip>
             <a:extLst>
               <a:ext uri="{96DAC541-7B7A-43D3-8B79-37D633B846F1}">
-                <asvg:svgBlip xmlns:asvg="http://schemas.microsoft.com/office/drawing/2016/SVG/main" r:embed="rId4"/>
+                <asvg:svgBlip xmlns:asvg="http://schemas.microsoft.com/office/drawing/2016/SVG/main" r:embed="rId3"/>
               </a:ext>
             </a:extLst>
           </a:blip>
@@ -15142,10 +17175,10 @@
           <p:nvPr/>
         </p:nvPicPr>
         <p:blipFill>
-          <a:blip r:embed="rId5">
+          <a:blip>
             <a:extLst>
               <a:ext uri="{96DAC541-7B7A-43D3-8B79-37D633B846F1}">
-                <asvg:svgBlip xmlns:asvg="http://schemas.microsoft.com/office/drawing/2016/SVG/main" r:embed="rId6"/>
+                <asvg:svgBlip xmlns:asvg="http://schemas.microsoft.com/office/drawing/2016/SVG/main" r:embed="rId4"/>
               </a:ext>
             </a:extLst>
           </a:blip>
@@ -15178,10 +17211,10 @@
           <p:nvPr/>
         </p:nvPicPr>
         <p:blipFill>
-          <a:blip r:embed="rId7">
+          <a:blip>
             <a:extLst>
               <a:ext uri="{96DAC541-7B7A-43D3-8B79-37D633B846F1}">
-                <asvg:svgBlip xmlns:asvg="http://schemas.microsoft.com/office/drawing/2016/SVG/main" r:embed="rId8"/>
+                <asvg:svgBlip xmlns:asvg="http://schemas.microsoft.com/office/drawing/2016/SVG/main" r:embed="rId5"/>
               </a:ext>
             </a:extLst>
           </a:blip>
@@ -15276,8 +17309,8 @@
           </a:p>
         </p:txBody>
       </p:sp>
-      <mc:AlternateContent xmlns:mc="http://schemas.openxmlformats.org/markup-compatibility/2006">
-        <mc:Choice xmlns:a14="http://schemas.microsoft.com/office/drawing/2010/main" Requires="a14">
+      <mc:AlternateContent xmlns:mc="http://schemas.openxmlformats.org/markup-compatibility/2006" xmlns:a14="http://schemas.microsoft.com/office/drawing/2010/main">
+        <mc:Choice Requires="a14">
           <p:sp>
             <p:nvSpPr>
               <p:cNvPr id="4" name="TextBox 3">
@@ -15890,7 +17923,7 @@
             </p:txBody>
           </p:sp>
         </mc:Choice>
-        <mc:Fallback>
+        <mc:Fallback xmlns="">
           <p:sp>
             <p:nvSpPr>
               <p:cNvPr id="4" name="TextBox 3">
@@ -16301,10 +18334,10 @@
           <p:nvPr/>
         </p:nvPicPr>
         <p:blipFill>
-          <a:blip r:embed="rId3">
+          <a:blip>
             <a:extLst>
               <a:ext uri="{96DAC541-7B7A-43D3-8B79-37D633B846F1}">
-                <asvg:svgBlip xmlns:asvg="http://schemas.microsoft.com/office/drawing/2016/SVG/main" r:embed="rId4"/>
+                <asvg:svgBlip xmlns:asvg="http://schemas.microsoft.com/office/drawing/2016/SVG/main" r:embed="rId3"/>
               </a:ext>
             </a:extLst>
           </a:blip>
@@ -16337,10 +18370,10 @@
           <p:nvPr/>
         </p:nvPicPr>
         <p:blipFill>
-          <a:blip r:embed="rId5">
+          <a:blip>
             <a:extLst>
               <a:ext uri="{96DAC541-7B7A-43D3-8B79-37D633B846F1}">
-                <asvg:svgBlip xmlns:asvg="http://schemas.microsoft.com/office/drawing/2016/SVG/main" r:embed="rId6"/>
+                <asvg:svgBlip xmlns:asvg="http://schemas.microsoft.com/office/drawing/2016/SVG/main" r:embed="rId4"/>
               </a:ext>
             </a:extLst>
           </a:blip>
@@ -16373,10 +18406,10 @@
           <p:nvPr/>
         </p:nvPicPr>
         <p:blipFill>
-          <a:blip r:embed="rId7">
+          <a:blip>
             <a:extLst>
               <a:ext uri="{96DAC541-7B7A-43D3-8B79-37D633B846F1}">
-                <asvg:svgBlip xmlns:asvg="http://schemas.microsoft.com/office/drawing/2016/SVG/main" r:embed="rId8"/>
+                <asvg:svgBlip xmlns:asvg="http://schemas.microsoft.com/office/drawing/2016/SVG/main" r:embed="rId5"/>
               </a:ext>
             </a:extLst>
           </a:blip>
@@ -16568,8 +18601,8 @@
           <a:chExt cx="0" cy="0"/>
         </a:xfrm>
       </p:grpSpPr>
-      <mc:AlternateContent xmlns:mc="http://schemas.openxmlformats.org/markup-compatibility/2006">
-        <mc:Choice xmlns:a14="http://schemas.microsoft.com/office/drawing/2010/main" Requires="a14">
+      <mc:AlternateContent xmlns:mc="http://schemas.openxmlformats.org/markup-compatibility/2006" xmlns:a14="http://schemas.microsoft.com/office/drawing/2010/main">
+        <mc:Choice Requires="a14">
           <p:sp>
             <p:nvSpPr>
               <p:cNvPr id="2" name="TextBox 1">
@@ -17182,7 +19215,7 @@
             </p:txBody>
           </p:sp>
         </mc:Choice>
-        <mc:Fallback>
+        <mc:Fallback xmlns="">
           <p:sp>
             <p:nvSpPr>
               <p:cNvPr id="2" name="TextBox 1">
@@ -17593,10 +19626,10 @@
           <p:nvPr/>
         </p:nvPicPr>
         <p:blipFill>
-          <a:blip r:embed="rId3">
+          <a:blip>
             <a:extLst>
               <a:ext uri="{96DAC541-7B7A-43D3-8B79-37D633B846F1}">
-                <asvg:svgBlip xmlns:asvg="http://schemas.microsoft.com/office/drawing/2016/SVG/main" r:embed="rId4"/>
+                <asvg:svgBlip xmlns:asvg="http://schemas.microsoft.com/office/drawing/2016/SVG/main" r:embed="rId3"/>
               </a:ext>
             </a:extLst>
           </a:blip>
@@ -17629,10 +19662,10 @@
           <p:nvPr/>
         </p:nvPicPr>
         <p:blipFill>
-          <a:blip r:embed="rId5">
+          <a:blip>
             <a:extLst>
               <a:ext uri="{96DAC541-7B7A-43D3-8B79-37D633B846F1}">
-                <asvg:svgBlip xmlns:asvg="http://schemas.microsoft.com/office/drawing/2016/SVG/main" r:embed="rId6"/>
+                <asvg:svgBlip xmlns:asvg="http://schemas.microsoft.com/office/drawing/2016/SVG/main" r:embed="rId4"/>
               </a:ext>
             </a:extLst>
           </a:blip>
@@ -17665,10 +19698,10 @@
           <p:nvPr/>
         </p:nvPicPr>
         <p:blipFill>
-          <a:blip r:embed="rId7">
+          <a:blip>
             <a:extLst>
               <a:ext uri="{96DAC541-7B7A-43D3-8B79-37D633B846F1}">
-                <asvg:svgBlip xmlns:asvg="http://schemas.microsoft.com/office/drawing/2016/SVG/main" r:embed="rId8"/>
+                <asvg:svgBlip xmlns:asvg="http://schemas.microsoft.com/office/drawing/2016/SVG/main" r:embed="rId5"/>
               </a:ext>
             </a:extLst>
           </a:blip>
@@ -17763,8 +19796,8 @@
           </a:p>
         </p:txBody>
       </p:sp>
-      <mc:AlternateContent xmlns:mc="http://schemas.openxmlformats.org/markup-compatibility/2006">
-        <mc:Choice xmlns:a14="http://schemas.microsoft.com/office/drawing/2010/main" Requires="a14">
+      <mc:AlternateContent xmlns:mc="http://schemas.openxmlformats.org/markup-compatibility/2006" xmlns:a14="http://schemas.microsoft.com/office/drawing/2010/main">
+        <mc:Choice Requires="a14">
           <p:sp>
             <p:nvSpPr>
               <p:cNvPr id="4" name="TextBox 3">
@@ -18377,7 +20410,7 @@
             </p:txBody>
           </p:sp>
         </mc:Choice>
-        <mc:Fallback>
+        <mc:Fallback xmlns="">
           <p:sp>
             <p:nvSpPr>
               <p:cNvPr id="4" name="TextBox 3">
@@ -18788,10 +20821,10 @@
           <p:nvPr/>
         </p:nvPicPr>
         <p:blipFill>
-          <a:blip r:embed="rId3">
+          <a:blip>
             <a:extLst>
               <a:ext uri="{96DAC541-7B7A-43D3-8B79-37D633B846F1}">
-                <asvg:svgBlip xmlns:asvg="http://schemas.microsoft.com/office/drawing/2016/SVG/main" r:embed="rId4"/>
+                <asvg:svgBlip xmlns:asvg="http://schemas.microsoft.com/office/drawing/2016/SVG/main" r:embed="rId3"/>
               </a:ext>
             </a:extLst>
           </a:blip>
@@ -18824,10 +20857,10 @@
           <p:nvPr/>
         </p:nvPicPr>
         <p:blipFill>
-          <a:blip r:embed="rId5">
+          <a:blip>
             <a:extLst>
               <a:ext uri="{96DAC541-7B7A-43D3-8B79-37D633B846F1}">
-                <asvg:svgBlip xmlns:asvg="http://schemas.microsoft.com/office/drawing/2016/SVG/main" r:embed="rId6"/>
+                <asvg:svgBlip xmlns:asvg="http://schemas.microsoft.com/office/drawing/2016/SVG/main" r:embed="rId4"/>
               </a:ext>
             </a:extLst>
           </a:blip>
@@ -18860,10 +20893,10 @@
           <p:nvPr/>
         </p:nvPicPr>
         <p:blipFill>
-          <a:blip r:embed="rId7">
+          <a:blip>
             <a:extLst>
               <a:ext uri="{96DAC541-7B7A-43D3-8B79-37D633B846F1}">
-                <asvg:svgBlip xmlns:asvg="http://schemas.microsoft.com/office/drawing/2016/SVG/main" r:embed="rId8"/>
+                <asvg:svgBlip xmlns:asvg="http://schemas.microsoft.com/office/drawing/2016/SVG/main" r:embed="rId5"/>
               </a:ext>
             </a:extLst>
           </a:blip>

</xml_diff>